<commit_message>
Add CodeQL attribution demo and references
Extend the office hour deck with a third runnable demo for Code Quality reporting attribution and a final slide linking every covered feature to its GitHub Changelog source.

Co-authored-by: Copilot App <223556219+Copilot@users.noreply.github.com>
</commit_message>
<xml_diff>
--- a/office-hours/GitHub-Actions-Office-Hours-Aug-Sep-2026.pptx
+++ b/office-hours/GitHub-Actions-Office-Hours-Aug-Sep-2026.pptx
@@ -21,6 +21,8 @@
     <p:sldId id="269" r:id="rId21"/>
     <p:sldId id="270" r:id="rId22"/>
     <p:sldId id="271" r:id="rId23"/>
+    <p:sldId id="272" r:id="rId24"/>
+    <p:sldId id="273" r:id="rId25"/>
   </p:sldIdLst>
   <p:sldSz cx="12191695" cy="6858000" type="screen4x3"/>
   <p:notesSz cx="6858000" cy="9144000"/>
@@ -579,7 +581,7 @@
               </a:defRPr>
             </a:pPr>
             <a:r>
-              <a:t>This session covers six GitHub Actions updates from August and early September 2026, two practical demonstrations, and five workflow performance techniques.</a:t>
+              <a:t>This session covers six GitHub Actions updates from August and early September 2026, three practical demonstrations, and five workflow performance techniques.</a:t>
             </a:r>
           </a:p>
           <a:p>
@@ -633,7 +635,7 @@
               </a:defRPr>
             </a:pPr>
             <a:r>
-              <a:t>• Set the promise: practical changes, two small demos, and actions attendees can take this week.</a:t>
+              <a:t>• Set the promise: practical changes, three small demos, and actions attendees can take this week.</a:t>
             </a:r>
           </a:p>
           <a:p>
@@ -749,7 +751,7 @@
               </a:defRPr>
             </a:pPr>
             <a:r>
-              <a:t>Timing: 4 minutes</a:t>
+              <a:t>Timing: 3 minutes</a:t>
             </a:r>
           </a:p>
           <a:p>
@@ -1232,7 +1234,7 @@
               </a:defRPr>
             </a:pPr>
             <a:r>
-              <a:t>A single manually dispatched workflow runs two independent jobs to demonstrate reusable-workflow provenance and least-privilege Dependabot access.</a:t>
+              <a:t>A single manually dispatched workflow runs three independent jobs to demonstrate reusable-workflow provenance, least-privilege Dependabot access, and separate CodeQL workload attribution.</a:t>
             </a:r>
           </a:p>
           <a:p>
@@ -1305,7 +1307,7 @@
               </a:defRPr>
             </a:pPr>
             <a:r>
-              <a:t>• While it starts, explain that the two jobs are independent.</a:t>
+              <a:t>• While it starts, explain that the three jobs are independent.</a:t>
             </a:r>
           </a:p>
           <a:p>
@@ -1888,7 +1890,7 @@
               </a:defRPr>
             </a:pPr>
             <a:r>
-              <a:t>Timing: 5 minutes</a:t>
+              <a:t>Timing: 3 minutes</a:t>
             </a:r>
           </a:p>
           <a:p>
@@ -1923,7 +1925,7 @@
               </a:defRPr>
             </a:pPr>
             <a:r>
-              <a:t>The highest-leverage performance improvements eliminate stale runs, reuse expensive deterministic work, prevent unnecessary jobs, control matrix growth, and distinguish queue time from execution time.</a:t>
+              <a:t>GitHub Code Quality runs now have a distinct actor and dynamic workflow path, allowing Actions reports and API consumers to separate quality analysis from code scanning.</a:t>
             </a:r>
           </a:p>
           <a:p>
@@ -1958,7 +1960,7 @@
               </a:defRPr>
             </a:pPr>
             <a:r>
-              <a:t>• Spend about 45 seconds on each tip.</a:t>
+              <a:t>• Open the code-quality-attribution job summary.</a:t>
             </a:r>
           </a:p>
           <a:p>
@@ -1977,7 +1979,7 @@
               </a:defRPr>
             </a:pPr>
             <a:r>
-              <a:t>• Concurrency avoids paying for obsolete commits.</a:t>
+              <a:t>• Compare the actor, expected path, run count, and latest observed path in each row.</a:t>
             </a:r>
           </a:p>
           <a:p>
@@ -1996,7 +1998,7 @@
               </a:defRPr>
             </a:pPr>
             <a:r>
-              <a:t>• Cache only expensive deterministic inputs.</a:t>
+              <a:t>• Explain that zero Code Quality runs means the feature is not enabled or has not completed a run in this repository.</a:t>
             </a:r>
           </a:p>
           <a:p>
@@ -2015,7 +2017,7 @@
               </a:defRPr>
             </a:pPr>
             <a:r>
-              <a:t>• Filters prevent runner allocation entirely.</a:t>
+              <a:t>• Use a prepared screenshot if needed.</a:t>
             </a:r>
           </a:p>
           <a:p>
@@ -2034,26 +2036,7 @@
               </a:defRPr>
             </a:pPr>
             <a:r>
-              <a:t>• Matrices often grow quadratically.</a:t>
-            </a:r>
-          </a:p>
-          <a:p>
-            <a:pPr>
-              <a:lnSpc>
-                <a:spcPct val="110000"/>
-              </a:lnSpc>
-              <a:spcAft>
-                <a:spcPts val="700"/>
-              </a:spcAft>
-              <a:defRPr sz="1500">
-                <a:solidFill>
-                  <a:srgbClr val="202020"/>
-                </a:solidFill>
-                <a:latin typeface="Aptos"/>
-              </a:defRPr>
-            </a:pPr>
-            <a:r>
-              <a:t>• Finally, inspect queue time separately: a faster build cannot fix runner scarcity.</a:t>
+              <a:t>• Close by showing which dashboard or billing filters must be updated.</a:t>
             </a:r>
           </a:p>
         </p:txBody>
@@ -2150,7 +2133,7 @@
               </a:defRPr>
             </a:pPr>
             <a:r>
-              <a:t>Timing: 3 minutes, then 15 minutes Q&amp;A</a:t>
+              <a:t>Timing: 5 minutes</a:t>
             </a:r>
           </a:p>
           <a:p>
@@ -2185,7 +2168,7 @@
               </a:defRPr>
             </a:pPr>
             <a:r>
-              <a:t>The immediate next steps are to test the new Arm64 image, review retention and reporting dependencies, and adopt narrower permissions plus native workflow provenance.</a:t>
+              <a:t>The highest-leverage performance improvements eliminate stale runs, reuse expensive deterministic work, prevent unnecessary jobs, control matrix growth, and distinguish queue time from execution time.</a:t>
             </a:r>
           </a:p>
           <a:p>
@@ -2220,7 +2203,7 @@
               </a:defRPr>
             </a:pPr>
             <a:r>
-              <a:t>• Recap the three action categories.</a:t>
+              <a:t>• Spend about 45 seconds on each tip.</a:t>
             </a:r>
           </a:p>
           <a:p>
@@ -2239,7 +2222,7 @@
               </a:defRPr>
             </a:pPr>
             <a:r>
-              <a:t>• Transition to questions.</a:t>
+              <a:t>• Concurrency avoids paying for obsolete commits.</a:t>
             </a:r>
           </a:p>
           <a:p>
@@ -2258,7 +2241,7 @@
               </a:defRPr>
             </a:pPr>
             <a:r>
-              <a:t>• Useful prompts: Which runner fleet is hardest to maintain?</a:t>
+              <a:t>• Cache only expensive deterministic inputs.</a:t>
             </a:r>
           </a:p>
           <a:p>
@@ -2277,7 +2260,7 @@
               </a:defRPr>
             </a:pPr>
             <a:r>
-              <a:t>• Where do shared workflows lack provenance?</a:t>
+              <a:t>• Filters prevent runner allocation entirely.</a:t>
             </a:r>
           </a:p>
           <a:p>
@@ -2296,7 +2279,455 @@
               </a:defRPr>
             </a:pPr>
             <a:r>
+              <a:t>• Matrices often grow quadratically.</a:t>
+            </a:r>
+          </a:p>
+          <a:p>
+            <a:pPr>
+              <a:lnSpc>
+                <a:spcPct val="110000"/>
+              </a:lnSpc>
+              <a:spcAft>
+                <a:spcPts val="700"/>
+              </a:spcAft>
+              <a:defRPr sz="1500">
+                <a:solidFill>
+                  <a:srgbClr val="202020"/>
+                </a:solidFill>
+                <a:latin typeface="Aptos"/>
+              </a:defRPr>
+            </a:pPr>
+            <a:r>
+              <a:t>• Finally, inspect queue time separately: a faster build cannot fix runner scarcity.</a:t>
+            </a:r>
+          </a:p>
+        </p:txBody>
+      </p:sp>
+      <p:sp>
+        <p:nvSpPr>
+          <p:cNvPr id="4" name="Slide Number Placeholder 3"/>
+          <p:cNvSpPr>
+            <a:spLocks noGrp="1"/>
+          </p:cNvSpPr>
+          <p:nvPr>
+            <p:ph type="sldNum" idx="5" sz="quarter"/>
+          </p:nvPr>
+        </p:nvSpPr>
+        <p:spPr/>
+      </p:sp>
+    </p:spTree>
+  </p:cSld>
+  <p:clrMapOvr>
+    <a:masterClrMapping/>
+  </p:clrMapOvr>
+</p:notes>
+</file>
+
+<file path=ppt/notesSlides/notesSlide17.xml><?xml version="1.0" encoding="utf-8"?>
+<p:notes xmlns:a="http://schemas.openxmlformats.org/drawingml/2006/main" xmlns:p="http://schemas.openxmlformats.org/presentationml/2006/main" xmlns:r="http://schemas.openxmlformats.org/officeDocument/2006/relationships">
+  <p:cSld>
+    <p:spTree>
+      <p:nvGrpSpPr>
+        <p:cNvPr id="1" name=""/>
+        <p:cNvGrpSpPr/>
+        <p:nvPr/>
+      </p:nvGrpSpPr>
+      <p:grpSpPr>
+        <a:xfrm>
+          <a:off x="0" y="0"/>
+          <a:ext cx="0" cy="0"/>
+          <a:chOff x="0" y="0"/>
+          <a:chExt cx="0" cy="0"/>
+        </a:xfrm>
+      </p:grpSpPr>
+      <p:sp>
+        <p:nvSpPr>
+          <p:cNvPr id="2" name="Slide Image Placeholder 1"/>
+          <p:cNvSpPr>
+            <a:spLocks noGrp="1"/>
+          </p:cNvSpPr>
+          <p:nvPr>
+            <p:ph type="sldImg" idx="2"/>
+          </p:nvPr>
+        </p:nvSpPr>
+        <p:spPr/>
+      </p:sp>
+      <p:sp>
+        <p:nvSpPr>
+          <p:cNvPr id="3" name="Notes Placeholder 2"/>
+          <p:cNvSpPr>
+            <a:spLocks noGrp="1"/>
+          </p:cNvSpPr>
+          <p:nvPr>
+            <p:ph type="body" idx="3" sz="quarter"/>
+          </p:nvPr>
+        </p:nvSpPr>
+        <p:spPr/>
+        <p:txBody>
+          <a:bodyPr wrap="square"/>
+          <a:lstStyle/>
+          <a:p>
+            <a:pPr>
+              <a:spcAft>
+                <a:spcPts val="800"/>
+              </a:spcAft>
+              <a:defRPr sz="2000" b="1">
+                <a:solidFill>
+                  <a:srgbClr val="1F4E79"/>
+                </a:solidFill>
+                <a:latin typeface="Aptos"/>
+              </a:defRPr>
+            </a:pPr>
+            <a:r>
+              <a:t>PRESENTER NOTES</a:t>
+            </a:r>
+          </a:p>
+          <a:p>
+            <a:pPr>
+              <a:spcAft>
+                <a:spcPts val="1200"/>
+              </a:spcAft>
+              <a:defRPr sz="1600" b="1">
+                <a:solidFill>
+                  <a:srgbClr val="2E7D32"/>
+                </a:solidFill>
+                <a:latin typeface="Aptos"/>
+              </a:defRPr>
+            </a:pPr>
+            <a:r>
+              <a:t>Timing: 3 minutes, then 15 minutes Q&amp;A</a:t>
+            </a:r>
+          </a:p>
+          <a:p>
+            <a:pPr>
+              <a:spcAft>
+                <a:spcPts val="500"/>
+              </a:spcAft>
+              <a:defRPr sz="1600" b="1">
+                <a:solidFill>
+                  <a:srgbClr val="1F4E79"/>
+                </a:solidFill>
+                <a:latin typeface="Aptos"/>
+              </a:defRPr>
+            </a:pPr>
+            <a:r>
+              <a:t>Feature summary</a:t>
+            </a:r>
+          </a:p>
+          <a:p>
+            <a:pPr>
+              <a:lnSpc>
+                <a:spcPct val="110000"/>
+              </a:lnSpc>
+              <a:spcAft>
+                <a:spcPts val="1200"/>
+              </a:spcAft>
+              <a:defRPr sz="1500">
+                <a:solidFill>
+                  <a:srgbClr val="202020"/>
+                </a:solidFill>
+                <a:latin typeface="Aptos"/>
+              </a:defRPr>
+            </a:pPr>
+            <a:r>
+              <a:t>The immediate next steps are to test the new Arm64 image, review retention and reporting dependencies, and adopt narrower permissions plus native workflow provenance.</a:t>
+            </a:r>
+          </a:p>
+          <a:p>
+            <a:pPr>
+              <a:spcAft>
+                <a:spcPts val="500"/>
+              </a:spcAft>
+              <a:defRPr sz="1600" b="1">
+                <a:solidFill>
+                  <a:srgbClr val="1F4E79"/>
+                </a:solidFill>
+                <a:latin typeface="Aptos"/>
+              </a:defRPr>
+            </a:pPr>
+            <a:r>
+              <a:t>Presenter cues</a:t>
+            </a:r>
+          </a:p>
+          <a:p>
+            <a:pPr>
+              <a:lnSpc>
+                <a:spcPct val="110000"/>
+              </a:lnSpc>
+              <a:spcAft>
+                <a:spcPts val="700"/>
+              </a:spcAft>
+              <a:defRPr sz="1500">
+                <a:solidFill>
+                  <a:srgbClr val="202020"/>
+                </a:solidFill>
+                <a:latin typeface="Aptos"/>
+              </a:defRPr>
+            </a:pPr>
+            <a:r>
+              <a:t>• Recap the three action categories.</a:t>
+            </a:r>
+          </a:p>
+          <a:p>
+            <a:pPr>
+              <a:lnSpc>
+                <a:spcPct val="110000"/>
+              </a:lnSpc>
+              <a:spcAft>
+                <a:spcPts val="700"/>
+              </a:spcAft>
+              <a:defRPr sz="1500">
+                <a:solidFill>
+                  <a:srgbClr val="202020"/>
+                </a:solidFill>
+                <a:latin typeface="Aptos"/>
+              </a:defRPr>
+            </a:pPr>
+            <a:r>
+              <a:t>• Transition to questions.</a:t>
+            </a:r>
+          </a:p>
+          <a:p>
+            <a:pPr>
+              <a:lnSpc>
+                <a:spcPct val="110000"/>
+              </a:lnSpc>
+              <a:spcAft>
+                <a:spcPts val="700"/>
+              </a:spcAft>
+              <a:defRPr sz="1500">
+                <a:solidFill>
+                  <a:srgbClr val="202020"/>
+                </a:solidFill>
+                <a:latin typeface="Aptos"/>
+              </a:defRPr>
+            </a:pPr>
+            <a:r>
+              <a:t>• Useful prompts: Which runner fleet is hardest to maintain?</a:t>
+            </a:r>
+          </a:p>
+          <a:p>
+            <a:pPr>
+              <a:lnSpc>
+                <a:spcPct val="110000"/>
+              </a:lnSpc>
+              <a:spcAft>
+                <a:spcPts val="700"/>
+              </a:spcAft>
+              <a:defRPr sz="1500">
+                <a:solidFill>
+                  <a:srgbClr val="202020"/>
+                </a:solidFill>
+                <a:latin typeface="Aptos"/>
+              </a:defRPr>
+            </a:pPr>
+            <a:r>
+              <a:t>• Where do shared workflows lack provenance?</a:t>
+            </a:r>
+          </a:p>
+          <a:p>
+            <a:pPr>
+              <a:lnSpc>
+                <a:spcPct val="110000"/>
+              </a:lnSpc>
+              <a:spcAft>
+                <a:spcPts val="700"/>
+              </a:spcAft>
+              <a:defRPr sz="1500">
+                <a:solidFill>
+                  <a:srgbClr val="202020"/>
+                </a:solidFill>
+                <a:latin typeface="Aptos"/>
+              </a:defRPr>
+            </a:pPr>
+            <a:r>
               <a:t>• What is the longest feedback-time bottleneck today?</a:t>
+            </a:r>
+          </a:p>
+        </p:txBody>
+      </p:sp>
+      <p:sp>
+        <p:nvSpPr>
+          <p:cNvPr id="4" name="Slide Number Placeholder 3"/>
+          <p:cNvSpPr>
+            <a:spLocks noGrp="1"/>
+          </p:cNvSpPr>
+          <p:nvPr>
+            <p:ph type="sldNum" idx="5" sz="quarter"/>
+          </p:nvPr>
+        </p:nvSpPr>
+        <p:spPr/>
+      </p:sp>
+    </p:spTree>
+  </p:cSld>
+  <p:clrMapOvr>
+    <a:masterClrMapping/>
+  </p:clrMapOvr>
+</p:notes>
+</file>
+
+<file path=ppt/notesSlides/notesSlide18.xml><?xml version="1.0" encoding="utf-8"?>
+<p:notes xmlns:a="http://schemas.openxmlformats.org/drawingml/2006/main" xmlns:p="http://schemas.openxmlformats.org/presentationml/2006/main" xmlns:r="http://schemas.openxmlformats.org/officeDocument/2006/relationships">
+  <p:cSld>
+    <p:spTree>
+      <p:nvGrpSpPr>
+        <p:cNvPr id="1" name=""/>
+        <p:cNvGrpSpPr/>
+        <p:nvPr/>
+      </p:nvGrpSpPr>
+      <p:grpSpPr>
+        <a:xfrm>
+          <a:off x="0" y="0"/>
+          <a:ext cx="0" cy="0"/>
+          <a:chOff x="0" y="0"/>
+          <a:chExt cx="0" cy="0"/>
+        </a:xfrm>
+      </p:grpSpPr>
+      <p:sp>
+        <p:nvSpPr>
+          <p:cNvPr id="2" name="Slide Image Placeholder 1"/>
+          <p:cNvSpPr>
+            <a:spLocks noGrp="1"/>
+          </p:cNvSpPr>
+          <p:nvPr>
+            <p:ph type="sldImg" idx="2"/>
+          </p:nvPr>
+        </p:nvSpPr>
+        <p:spPr/>
+      </p:sp>
+      <p:sp>
+        <p:nvSpPr>
+          <p:cNvPr id="3" name="Notes Placeholder 2"/>
+          <p:cNvSpPr>
+            <a:spLocks noGrp="1"/>
+          </p:cNvSpPr>
+          <p:nvPr>
+            <p:ph type="body" idx="3" sz="quarter"/>
+          </p:nvPr>
+        </p:nvSpPr>
+        <p:spPr/>
+        <p:txBody>
+          <a:bodyPr wrap="square"/>
+          <a:lstStyle/>
+          <a:p>
+            <a:pPr>
+              <a:spcAft>
+                <a:spcPts val="800"/>
+              </a:spcAft>
+              <a:defRPr sz="2000" b="1">
+                <a:solidFill>
+                  <a:srgbClr val="1F4E79"/>
+                </a:solidFill>
+                <a:latin typeface="Aptos"/>
+              </a:defRPr>
+            </a:pPr>
+            <a:r>
+              <a:t>PRESENTER NOTES</a:t>
+            </a:r>
+          </a:p>
+          <a:p>
+            <a:pPr>
+              <a:spcAft>
+                <a:spcPts val="1200"/>
+              </a:spcAft>
+              <a:defRPr sz="1600" b="1">
+                <a:solidFill>
+                  <a:srgbClr val="2E7D32"/>
+                </a:solidFill>
+                <a:latin typeface="Aptos"/>
+              </a:defRPr>
+            </a:pPr>
+            <a:r>
+              <a:t>Timing: Reference slide; no presentation time required</a:t>
+            </a:r>
+          </a:p>
+          <a:p>
+            <a:pPr>
+              <a:spcAft>
+                <a:spcPts val="500"/>
+              </a:spcAft>
+              <a:defRPr sz="1600" b="1">
+                <a:solidFill>
+                  <a:srgbClr val="1F4E79"/>
+                </a:solidFill>
+                <a:latin typeface="Aptos"/>
+              </a:defRPr>
+            </a:pPr>
+            <a:r>
+              <a:t>Feature summary</a:t>
+            </a:r>
+          </a:p>
+          <a:p>
+            <a:pPr>
+              <a:lnSpc>
+                <a:spcPct val="110000"/>
+              </a:lnSpc>
+              <a:spcAft>
+                <a:spcPts val="1200"/>
+              </a:spcAft>
+              <a:defRPr sz="1500">
+                <a:solidFill>
+                  <a:srgbClr val="202020"/>
+                </a:solidFill>
+                <a:latin typeface="Aptos"/>
+              </a:defRPr>
+            </a:pPr>
+            <a:r>
+              <a:t>This slide provides the official GitHub Changelog source for every feature covered in the presentation.</a:t>
+            </a:r>
+          </a:p>
+          <a:p>
+            <a:pPr>
+              <a:spcAft>
+                <a:spcPts val="500"/>
+              </a:spcAft>
+              <a:defRPr sz="1600" b="1">
+                <a:solidFill>
+                  <a:srgbClr val="1F4E79"/>
+                </a:solidFill>
+                <a:latin typeface="Aptos"/>
+              </a:defRPr>
+            </a:pPr>
+            <a:r>
+              <a:t>Presenter cues</a:t>
+            </a:r>
+          </a:p>
+          <a:p>
+            <a:pPr>
+              <a:lnSpc>
+                <a:spcPct val="110000"/>
+              </a:lnSpc>
+              <a:spcAft>
+                <a:spcPts val="700"/>
+              </a:spcAft>
+              <a:defRPr sz="1500">
+                <a:solidFill>
+                  <a:srgbClr val="202020"/>
+                </a:solidFill>
+                <a:latin typeface="Aptos"/>
+              </a:defRPr>
+            </a:pPr>
+            <a:r>
+              <a:t>• Leave this slide displayed after Q&amp;A or share it with attendees as a follow-up resource.</a:t>
+            </a:r>
+          </a:p>
+          <a:p>
+            <a:pPr>
+              <a:lnSpc>
+                <a:spcPct val="110000"/>
+              </a:lnSpc>
+              <a:spcAft>
+                <a:spcPts val="700"/>
+              </a:spcAft>
+              <a:defRPr sz="1500">
+                <a:solidFill>
+                  <a:srgbClr val="202020"/>
+                </a:solidFill>
+                <a:latin typeface="Aptos"/>
+              </a:defRPr>
+            </a:pPr>
+            <a:r>
+              <a:t>• Each URL is clickable.</a:t>
             </a:r>
           </a:p>
         </p:txBody>
@@ -2784,7 +3215,7 @@
               </a:defRPr>
             </a:pPr>
             <a:r>
-              <a:t>Timing: 3 minutes</a:t>
+              <a:t>Timing: 2 minutes</a:t>
             </a:r>
           </a:p>
           <a:p>
@@ -3175,7 +3606,7 @@
               </a:defRPr>
             </a:pPr>
             <a:r>
-              <a:t>Timing: 4 minutes</a:t>
+              <a:t>Timing: 3 minutes</a:t>
             </a:r>
           </a:p>
           <a:p>
@@ -7130,7 +7561,7 @@
                 </a:solidFill>
                 <a:latin typeface="Aptos"/>
               </a:rPr>
-              <a:t>Six updates · two live demos · five performance moves</a:t>
+              <a:t>Six updates · three live demos · five performance moves</a:t>
             </a:r>
           </a:p>
         </p:txBody>
@@ -8901,7 +9332,7 @@
                 </a:solidFill>
                 <a:latin typeface="Aptos"/>
               </a:rPr>
-              <a:t>Demo setup: one dispatch, two visible results</a:t>
+              <a:t>Demo setup: one dispatch, three visible results</a:t>
             </a:r>
           </a:p>
         </p:txBody>
@@ -9144,8 +9575,8 @@
         </p:nvSpPr>
         <p:spPr>
           <a:xfrm>
-            <a:off x="4892040" y="2057400"/>
-            <a:ext cx="2743200" cy="1143000"/>
+            <a:off x="4892040" y="1783080"/>
+            <a:ext cx="2743200" cy="960120"/>
           </a:xfrm>
           <a:prstGeom prst="roundRect">
             <a:avLst/>
@@ -9189,7 +9620,7 @@
         </p:nvSpPr>
         <p:spPr>
           <a:xfrm>
-            <a:off x="4892040" y="2432304"/>
+            <a:off x="4892040" y="2112264"/>
             <a:ext cx="2743200" cy="274320"/>
           </a:xfrm>
           <a:prstGeom prst="rect">
@@ -9205,7 +9636,7 @@
           <a:p>
             <a:pPr algn="ctr"/>
             <a:r>
-              <a:rPr sz="1700" b="1">
+              <a:rPr sz="1600" b="1">
                 <a:solidFill>
                   <a:srgbClr val="F0F6FC"/>
                 </a:solidFill>
@@ -9224,8 +9655,8 @@
         </p:nvSpPr>
         <p:spPr>
           <a:xfrm>
-            <a:off x="4892040" y="3703320"/>
-            <a:ext cx="2743200" cy="1143000"/>
+            <a:off x="4892040" y="3063240"/>
+            <a:ext cx="2743200" cy="960120"/>
           </a:xfrm>
           <a:prstGeom prst="roundRect">
             <a:avLst/>
@@ -9269,7 +9700,7 @@
         </p:nvSpPr>
         <p:spPr>
           <a:xfrm>
-            <a:off x="4892040" y="4078224"/>
+            <a:off x="4892040" y="3392424"/>
             <a:ext cx="2743200" cy="274320"/>
           </a:xfrm>
           <a:prstGeom prst="rect">
@@ -9285,7 +9716,7 @@
           <a:p>
             <a:pPr algn="ctr"/>
             <a:r>
-              <a:rPr sz="1700" b="1">
+              <a:rPr sz="1600" b="1">
                 <a:solidFill>
                   <a:srgbClr val="F0F6FC"/>
                 </a:solidFill>
@@ -9298,7 +9729,87 @@
       </p:sp>
       <p:sp>
         <p:nvSpPr>
-          <p:cNvPr id="14" name="TextBox 13"/>
+          <p:cNvPr id="14" name="Rounded Rectangle 13"/>
+          <p:cNvSpPr/>
+          <p:nvPr/>
+        </p:nvSpPr>
+        <p:spPr>
+          <a:xfrm>
+            <a:off x="4892040" y="4343400"/>
+            <a:ext cx="2743200" cy="960120"/>
+          </a:xfrm>
+          <a:prstGeom prst="roundRect">
+            <a:avLst/>
+          </a:prstGeom>
+          <a:solidFill>
+            <a:srgbClr val="161B22"/>
+          </a:solidFill>
+          <a:ln>
+            <a:solidFill>
+              <a:srgbClr val="58A6FF"/>
+            </a:solidFill>
+          </a:ln>
+        </p:spPr>
+        <p:style>
+          <a:lnRef idx="1">
+            <a:schemeClr val="accent1"/>
+          </a:lnRef>
+          <a:fillRef idx="3">
+            <a:schemeClr val="accent1"/>
+          </a:fillRef>
+          <a:effectRef idx="2">
+            <a:schemeClr val="accent1"/>
+          </a:effectRef>
+          <a:fontRef idx="minor">
+            <a:schemeClr val="lt1"/>
+          </a:fontRef>
+        </p:style>
+        <p:txBody>
+          <a:bodyPr rtlCol="0" anchor="ctr"/>
+          <a:lstStyle/>
+          <a:p>
+            <a:pPr algn="ctr"/>
+          </a:p>
+        </p:txBody>
+      </p:sp>
+      <p:sp>
+        <p:nvSpPr>
+          <p:cNvPr id="15" name="TextBox 14"/>
+          <p:cNvSpPr txBox="1"/>
+          <p:nvPr/>
+        </p:nvSpPr>
+        <p:spPr>
+          <a:xfrm>
+            <a:off x="4892040" y="4672584"/>
+            <a:ext cx="2743200" cy="274320"/>
+          </a:xfrm>
+          <a:prstGeom prst="rect">
+            <a:avLst/>
+          </a:prstGeom>
+          <a:noFill/>
+        </p:spPr>
+        <p:txBody>
+          <a:bodyPr wrap="square" lIns="36576" rIns="36576" tIns="36576" bIns="36576" anchor="t">
+            <a:spAutoFit/>
+          </a:bodyPr>
+          <a:lstStyle/>
+          <a:p>
+            <a:pPr algn="ctr"/>
+            <a:r>
+              <a:rPr sz="1600" b="1">
+                <a:solidFill>
+                  <a:srgbClr val="F0F6FC"/>
+                </a:solidFill>
+                <a:latin typeface="Aptos"/>
+              </a:rPr>
+              <a:t>CodeQL attribution</a:t>
+            </a:r>
+          </a:p>
+        </p:txBody>
+      </p:sp>
+      <p:sp>
+        <p:nvSpPr>
+          <p:cNvPr id="16" name="TextBox 15"/>
           <p:cNvSpPr txBox="1"/>
           <p:nvPr/>
         </p:nvSpPr>
@@ -9333,7 +9844,7 @@
       </p:sp>
       <p:sp>
         <p:nvSpPr>
-          <p:cNvPr id="15" name="Rounded Rectangle 14"/>
+          <p:cNvPr id="17" name="Rounded Rectangle 16"/>
           <p:cNvSpPr/>
           <p:nvPr/>
         </p:nvSpPr>
@@ -9378,7 +9889,7 @@
       </p:sp>
       <p:sp>
         <p:nvSpPr>
-          <p:cNvPr id="16" name="TextBox 15"/>
+          <p:cNvPr id="18" name="TextBox 17"/>
           <p:cNvSpPr txBox="1"/>
           <p:nvPr/>
         </p:nvSpPr>
@@ -9413,7 +9924,7 @@
       </p:sp>
       <p:sp>
         <p:nvSpPr>
-          <p:cNvPr id="17" name="TextBox 16"/>
+          <p:cNvPr id="19" name="TextBox 18"/>
           <p:cNvSpPr txBox="1"/>
           <p:nvPr/>
         </p:nvSpPr>
@@ -9448,7 +9959,7 @@
       </p:sp>
       <p:sp>
         <p:nvSpPr>
-          <p:cNvPr id="18" name="TextBox 17"/>
+          <p:cNvPr id="20" name="TextBox 19"/>
           <p:cNvSpPr txBox="1"/>
           <p:nvPr/>
         </p:nvSpPr>
@@ -10636,7 +11147,7 @@
                 </a:solidFill>
                 <a:latin typeface="Aptos"/>
               </a:rPr>
-              <a:t>FINAL FIVE MINUTES</a:t>
+              <a:t>LIVE DEMO · 3 MINUTES</a:t>
             </a:r>
           </a:p>
         </p:txBody>
@@ -10671,7 +11182,7 @@
                 </a:solidFill>
                 <a:latin typeface="Aptos"/>
               </a:rPr>
-              <a:t>Five performance moves with outsized returns</a:t>
+              <a:t>Demo 3: separate CodeQL workload attribution</a:t>
             </a:r>
           </a:p>
         </p:txBody>
@@ -10764,14 +11275,176 @@
         </p:nvSpPr>
         <p:spPr>
           <a:xfrm>
-            <a:off x="777240" y="1700784"/>
-            <a:ext cx="530352" cy="530352"/>
+            <a:off x="777240" y="1828800"/>
+            <a:ext cx="4937760" cy="1234440"/>
           </a:xfrm>
           <a:prstGeom prst="roundRect">
             <a:avLst/>
           </a:prstGeom>
           <a:solidFill>
-            <a:srgbClr val="58A6FF"/>
+            <a:srgbClr val="161B22"/>
+          </a:solidFill>
+          <a:ln>
+            <a:solidFill>
+              <a:srgbClr val="21262D"/>
+            </a:solidFill>
+          </a:ln>
+        </p:spPr>
+        <p:style>
+          <a:lnRef idx="1">
+            <a:schemeClr val="accent1"/>
+          </a:lnRef>
+          <a:fillRef idx="3">
+            <a:schemeClr val="accent1"/>
+          </a:fillRef>
+          <a:effectRef idx="2">
+            <a:schemeClr val="accent1"/>
+          </a:effectRef>
+          <a:fontRef idx="minor">
+            <a:schemeClr val="lt1"/>
+          </a:fontRef>
+        </p:style>
+        <p:txBody>
+          <a:bodyPr rtlCol="0" anchor="ctr"/>
+          <a:lstStyle/>
+          <a:p>
+            <a:pPr algn="ctr"/>
+          </a:p>
+        </p:txBody>
+      </p:sp>
+      <p:sp>
+        <p:nvSpPr>
+          <p:cNvPr id="7" name="TextBox 6"/>
+          <p:cNvSpPr txBox="1"/>
+          <p:nvPr/>
+        </p:nvSpPr>
+        <p:spPr>
+          <a:xfrm>
+            <a:off x="1005840" y="2029968"/>
+            <a:ext cx="4480560" cy="868680"/>
+          </a:xfrm>
+          <a:prstGeom prst="rect">
+            <a:avLst/>
+          </a:prstGeom>
+          <a:noFill/>
+        </p:spPr>
+        <p:txBody>
+          <a:bodyPr wrap="square" lIns="36576" rIns="36576" tIns="36576" bIns="36576" anchor="t">
+            <a:spAutoFit/>
+          </a:bodyPr>
+          <a:lstStyle/>
+          <a:p>
+            <a:pPr algn="l"/>
+            <a:r>
+              <a:rPr sz="1600" b="0">
+                <a:solidFill>
+                  <a:srgbClr val="F0F6FC"/>
+                </a:solidFill>
+                <a:latin typeface="Cascadia Mono"/>
+              </a:rPr>
+              <a:t>gh api "repos/$GITHUB_REPOSITORY/
+  actions/runs?actor=github-code-quality"</a:t>
+            </a:r>
+          </a:p>
+        </p:txBody>
+      </p:sp>
+      <p:sp>
+        <p:nvSpPr>
+          <p:cNvPr id="8" name="Rounded Rectangle 7"/>
+          <p:cNvSpPr/>
+          <p:nvPr/>
+        </p:nvSpPr>
+        <p:spPr>
+          <a:xfrm>
+            <a:off x="6080760" y="1828800"/>
+            <a:ext cx="5303520" cy="1234440"/>
+          </a:xfrm>
+          <a:prstGeom prst="roundRect">
+            <a:avLst/>
+          </a:prstGeom>
+          <a:solidFill>
+            <a:srgbClr val="161B22"/>
+          </a:solidFill>
+          <a:ln>
+            <a:solidFill>
+              <a:srgbClr val="21262D"/>
+            </a:solidFill>
+          </a:ln>
+        </p:spPr>
+        <p:style>
+          <a:lnRef idx="1">
+            <a:schemeClr val="accent1"/>
+          </a:lnRef>
+          <a:fillRef idx="3">
+            <a:schemeClr val="accent1"/>
+          </a:fillRef>
+          <a:effectRef idx="2">
+            <a:schemeClr val="accent1"/>
+          </a:effectRef>
+          <a:fontRef idx="minor">
+            <a:schemeClr val="lt1"/>
+          </a:fontRef>
+        </p:style>
+        <p:txBody>
+          <a:bodyPr rtlCol="0" anchor="ctr"/>
+          <a:lstStyle/>
+          <a:p>
+            <a:pPr algn="ctr"/>
+          </a:p>
+        </p:txBody>
+      </p:sp>
+      <p:sp>
+        <p:nvSpPr>
+          <p:cNvPr id="9" name="TextBox 8"/>
+          <p:cNvSpPr txBox="1"/>
+          <p:nvPr/>
+        </p:nvSpPr>
+        <p:spPr>
+          <a:xfrm>
+            <a:off x="6309360" y="2029968"/>
+            <a:ext cx="4846320" cy="868680"/>
+          </a:xfrm>
+          <a:prstGeom prst="rect">
+            <a:avLst/>
+          </a:prstGeom>
+          <a:noFill/>
+        </p:spPr>
+        <p:txBody>
+          <a:bodyPr wrap="square" lIns="36576" rIns="36576" tIns="36576" bIns="36576" anchor="t">
+            <a:spAutoFit/>
+          </a:bodyPr>
+          <a:lstStyle/>
+          <a:p>
+            <a:pPr algn="l"/>
+            <a:r>
+              <a:rPr sz="1600" b="0">
+                <a:solidFill>
+                  <a:srgbClr val="F0F6FC"/>
+                </a:solidFill>
+                <a:latin typeface="Cascadia Mono"/>
+              </a:rPr>
+              <a:t>gh api "repos/$GITHUB_REPOSITORY/
+  actions/runs?actor=github-advanced-security"</a:t>
+            </a:r>
+          </a:p>
+        </p:txBody>
+      </p:sp>
+      <p:sp>
+        <p:nvSpPr>
+          <p:cNvPr id="10" name="Rounded Rectangle 9"/>
+          <p:cNvSpPr/>
+          <p:nvPr/>
+        </p:nvSpPr>
+        <p:spPr>
+          <a:xfrm>
+            <a:off x="777240" y="3429000"/>
+            <a:ext cx="4937760" cy="1371600"/>
+          </a:xfrm>
+          <a:prstGeom prst="roundRect">
+            <a:avLst/>
+          </a:prstGeom>
+          <a:solidFill>
+            <a:srgbClr val="161B22"/>
           </a:solidFill>
           <a:ln>
             <a:solidFill>
@@ -10803,14 +11476,14 @@
       </p:sp>
       <p:sp>
         <p:nvSpPr>
-          <p:cNvPr id="7" name="TextBox 6"/>
-          <p:cNvSpPr txBox="1"/>
-          <p:nvPr/>
-        </p:nvSpPr>
-        <p:spPr>
-          <a:xfrm>
-            <a:off x="777240" y="1828800"/>
-            <a:ext cx="530352" cy="219456"/>
+          <p:cNvPr id="11" name="TextBox 10"/>
+          <p:cNvSpPr txBox="1"/>
+          <p:nvPr/>
+        </p:nvSpPr>
+        <p:spPr>
+          <a:xfrm>
+            <a:off x="1024128" y="3675887"/>
+            <a:ext cx="1828800" cy="274320"/>
           </a:xfrm>
           <a:prstGeom prst="rect">
             <a:avLst/>
@@ -10823,29 +11496,29 @@
           </a:bodyPr>
           <a:lstStyle/>
           <a:p>
-            <a:pPr algn="ctr"/>
-            <a:r>
-              <a:rPr sz="1300" b="1">
-                <a:solidFill>
-                  <a:srgbClr val="0D1117"/>
-                </a:solidFill>
-                <a:latin typeface="Aptos"/>
-              </a:rPr>
-              <a:t>1</a:t>
-            </a:r>
-          </a:p>
-        </p:txBody>
-      </p:sp>
-      <p:sp>
-        <p:nvSpPr>
-          <p:cNvPr id="8" name="TextBox 7"/>
-          <p:cNvSpPr txBox="1"/>
-          <p:nvPr/>
-        </p:nvSpPr>
-        <p:spPr>
-          <a:xfrm>
-            <a:off x="1536192" y="1691640"/>
-            <a:ext cx="2560320" cy="310896"/>
+            <a:pPr algn="l"/>
+            <a:r>
+              <a:rPr sz="1800" b="1">
+                <a:solidFill>
+                  <a:srgbClr val="58A6FF"/>
+                </a:solidFill>
+                <a:latin typeface="Aptos"/>
+              </a:rPr>
+              <a:t>Code Quality</a:t>
+            </a:r>
+          </a:p>
+        </p:txBody>
+      </p:sp>
+      <p:sp>
+        <p:nvSpPr>
+          <p:cNvPr id="12" name="TextBox 11"/>
+          <p:cNvSpPr txBox="1"/>
+          <p:nvPr/>
+        </p:nvSpPr>
+        <p:spPr>
+          <a:xfrm>
+            <a:off x="1024128" y="4050791"/>
+            <a:ext cx="4114800" cy="246888"/>
           </a:xfrm>
           <a:prstGeom prst="rect">
             <a:avLst/>
@@ -10860,27 +11533,27 @@
           <a:p>
             <a:pPr algn="l"/>
             <a:r>
-              <a:rPr sz="1800" b="1">
+              <a:rPr sz="1400" b="0">
                 <a:solidFill>
                   <a:srgbClr val="F0F6FC"/>
                 </a:solidFill>
-                <a:latin typeface="Aptos"/>
-              </a:rPr>
-              <a:t>Cancel stale work</a:t>
-            </a:r>
-          </a:p>
-        </p:txBody>
-      </p:sp>
-      <p:sp>
-        <p:nvSpPr>
-          <p:cNvPr id="9" name="TextBox 8"/>
-          <p:cNvSpPr txBox="1"/>
-          <p:nvPr/>
-        </p:nvSpPr>
-        <p:spPr>
-          <a:xfrm>
-            <a:off x="3886200" y="1719072"/>
-            <a:ext cx="7223760" cy="292608"/>
+                <a:latin typeface="Cascadia Mono"/>
+              </a:rPr>
+              <a:t>actor: github-code-quality</a:t>
+            </a:r>
+          </a:p>
+        </p:txBody>
+      </p:sp>
+      <p:sp>
+        <p:nvSpPr>
+          <p:cNvPr id="13" name="TextBox 12"/>
+          <p:cNvSpPr txBox="1"/>
+          <p:nvPr/>
+        </p:nvSpPr>
+        <p:spPr>
+          <a:xfrm>
+            <a:off x="1024128" y="4379976"/>
+            <a:ext cx="4389120" cy="246888"/>
           </a:xfrm>
           <a:prstGeom prst="rect">
             <a:avLst/>
@@ -10895,33 +11568,33 @@
           <a:p>
             <a:pPr algn="l"/>
             <a:r>
-              <a:rPr sz="1500" b="0">
-                <a:solidFill>
-                  <a:srgbClr val="8B949E"/>
-                </a:solidFill>
-                <a:latin typeface="Aptos"/>
-              </a:rPr>
-              <a:t>Use concurrency groups with cancel-in-progress for PRs.</a:t>
-            </a:r>
-          </a:p>
-        </p:txBody>
-      </p:sp>
-      <p:sp>
-        <p:nvSpPr>
-          <p:cNvPr id="10" name="Rounded Rectangle 9"/>
+              <a:rPr sz="1300" b="0">
+                <a:solidFill>
+                  <a:srgbClr val="F0F6FC"/>
+                </a:solidFill>
+                <a:latin typeface="Cascadia Mono"/>
+              </a:rPr>
+              <a:t>path: dynamic/github-code-quality/codeql</a:t>
+            </a:r>
+          </a:p>
+        </p:txBody>
+      </p:sp>
+      <p:sp>
+        <p:nvSpPr>
+          <p:cNvPr id="14" name="Rounded Rectangle 13"/>
           <p:cNvSpPr/>
           <p:nvPr/>
         </p:nvSpPr>
         <p:spPr>
           <a:xfrm>
-            <a:off x="777240" y="2569464"/>
-            <a:ext cx="530352" cy="530352"/>
+            <a:off x="6080760" y="3429000"/>
+            <a:ext cx="5303520" cy="1371600"/>
           </a:xfrm>
           <a:prstGeom prst="roundRect">
             <a:avLst/>
           </a:prstGeom>
           <a:solidFill>
-            <a:srgbClr val="BC8CFF"/>
+            <a:srgbClr val="161B22"/>
           </a:solidFill>
           <a:ln>
             <a:solidFill>
@@ -10953,14 +11626,14 @@
       </p:sp>
       <p:sp>
         <p:nvSpPr>
-          <p:cNvPr id="11" name="TextBox 10"/>
-          <p:cNvSpPr txBox="1"/>
-          <p:nvPr/>
-        </p:nvSpPr>
-        <p:spPr>
-          <a:xfrm>
-            <a:off x="777240" y="2697480"/>
-            <a:ext cx="530352" cy="219456"/>
+          <p:cNvPr id="15" name="TextBox 14"/>
+          <p:cNvSpPr txBox="1"/>
+          <p:nvPr/>
+        </p:nvSpPr>
+        <p:spPr>
+          <a:xfrm>
+            <a:off x="6327648" y="3675887"/>
+            <a:ext cx="1828800" cy="274320"/>
           </a:xfrm>
           <a:prstGeom prst="rect">
             <a:avLst/>
@@ -10973,622 +11646,127 @@
           </a:bodyPr>
           <a:lstStyle/>
           <a:p>
+            <a:pPr algn="l"/>
+            <a:r>
+              <a:rPr sz="1800" b="1">
+                <a:solidFill>
+                  <a:srgbClr val="BC8CFF"/>
+                </a:solidFill>
+                <a:latin typeface="Aptos"/>
+              </a:rPr>
+              <a:t>Code scanning</a:t>
+            </a:r>
+          </a:p>
+        </p:txBody>
+      </p:sp>
+      <p:sp>
+        <p:nvSpPr>
+          <p:cNvPr id="16" name="TextBox 15"/>
+          <p:cNvSpPr txBox="1"/>
+          <p:nvPr/>
+        </p:nvSpPr>
+        <p:spPr>
+          <a:xfrm>
+            <a:off x="6327648" y="4050791"/>
+            <a:ext cx="4389120" cy="246888"/>
+          </a:xfrm>
+          <a:prstGeom prst="rect">
+            <a:avLst/>
+          </a:prstGeom>
+          <a:noFill/>
+        </p:spPr>
+        <p:txBody>
+          <a:bodyPr wrap="square" lIns="36576" rIns="36576" tIns="36576" bIns="36576" anchor="t">
+            <a:spAutoFit/>
+          </a:bodyPr>
+          <a:lstStyle/>
+          <a:p>
+            <a:pPr algn="l"/>
+            <a:r>
+              <a:rPr sz="1400" b="0">
+                <a:solidFill>
+                  <a:srgbClr val="F0F6FC"/>
+                </a:solidFill>
+                <a:latin typeface="Cascadia Mono"/>
+              </a:rPr>
+              <a:t>actor: github-advanced-security</a:t>
+            </a:r>
+          </a:p>
+        </p:txBody>
+      </p:sp>
+      <p:sp>
+        <p:nvSpPr>
+          <p:cNvPr id="17" name="TextBox 16"/>
+          <p:cNvSpPr txBox="1"/>
+          <p:nvPr/>
+        </p:nvSpPr>
+        <p:spPr>
+          <a:xfrm>
+            <a:off x="6327648" y="4379976"/>
+            <a:ext cx="4572000" cy="246888"/>
+          </a:xfrm>
+          <a:prstGeom prst="rect">
+            <a:avLst/>
+          </a:prstGeom>
+          <a:noFill/>
+        </p:spPr>
+        <p:txBody>
+          <a:bodyPr wrap="square" lIns="36576" rIns="36576" tIns="36576" bIns="36576" anchor="t">
+            <a:spAutoFit/>
+          </a:bodyPr>
+          <a:lstStyle/>
+          <a:p>
+            <a:pPr algn="l"/>
+            <a:r>
+              <a:rPr sz="1300" b="0">
+                <a:solidFill>
+                  <a:srgbClr val="F0F6FC"/>
+                </a:solidFill>
+                <a:latin typeface="Cascadia Mono"/>
+              </a:rPr>
+              <a:t>path: dynamic/github-code-scanning/codeql</a:t>
+            </a:r>
+          </a:p>
+        </p:txBody>
+      </p:sp>
+      <p:sp>
+        <p:nvSpPr>
+          <p:cNvPr id="18" name="TextBox 17"/>
+          <p:cNvSpPr txBox="1"/>
+          <p:nvPr/>
+        </p:nvSpPr>
+        <p:spPr>
+          <a:xfrm>
+            <a:off x="1005840" y="5532120"/>
+            <a:ext cx="10149840" cy="365760"/>
+          </a:xfrm>
+          <a:prstGeom prst="rect">
+            <a:avLst/>
+          </a:prstGeom>
+          <a:noFill/>
+        </p:spPr>
+        <p:txBody>
+          <a:bodyPr wrap="square" lIns="36576" rIns="36576" tIns="36576" bIns="36576" anchor="t">
+            <a:spAutoFit/>
+          </a:bodyPr>
+          <a:lstStyle/>
+          <a:p>
             <a:pPr algn="ctr"/>
             <a:r>
-              <a:rPr sz="1300" b="1">
-                <a:solidFill>
-                  <a:srgbClr val="0D1117"/>
-                </a:solidFill>
-                <a:latin typeface="Aptos"/>
-              </a:rPr>
-              <a:t>2</a:t>
-            </a:r>
-          </a:p>
-        </p:txBody>
-      </p:sp>
-      <p:sp>
-        <p:nvSpPr>
-          <p:cNvPr id="12" name="TextBox 11"/>
-          <p:cNvSpPr txBox="1"/>
-          <p:nvPr/>
-        </p:nvSpPr>
-        <p:spPr>
-          <a:xfrm>
-            <a:off x="1536192" y="2560320"/>
-            <a:ext cx="2560320" cy="310896"/>
-          </a:xfrm>
-          <a:prstGeom prst="rect">
-            <a:avLst/>
-          </a:prstGeom>
-          <a:noFill/>
-        </p:spPr>
-        <p:txBody>
-          <a:bodyPr wrap="square" lIns="36576" rIns="36576" tIns="36576" bIns="36576" anchor="t">
-            <a:spAutoFit/>
-          </a:bodyPr>
-          <a:lstStyle/>
-          <a:p>
-            <a:pPr algn="l"/>
-            <a:r>
-              <a:rPr sz="1800" b="1">
-                <a:solidFill>
-                  <a:srgbClr val="F0F6FC"/>
-                </a:solidFill>
-                <a:latin typeface="Aptos"/>
-              </a:rPr>
-              <a:t>Cache with intent</a:t>
-            </a:r>
-          </a:p>
-        </p:txBody>
-      </p:sp>
-      <p:sp>
-        <p:nvSpPr>
-          <p:cNvPr id="13" name="TextBox 12"/>
-          <p:cNvSpPr txBox="1"/>
-          <p:nvPr/>
-        </p:nvSpPr>
-        <p:spPr>
-          <a:xfrm>
-            <a:off x="3886200" y="2587752"/>
-            <a:ext cx="7223760" cy="292608"/>
-          </a:xfrm>
-          <a:prstGeom prst="rect">
-            <a:avLst/>
-          </a:prstGeom>
-          <a:noFill/>
-        </p:spPr>
-        <p:txBody>
-          <a:bodyPr wrap="square" lIns="36576" rIns="36576" tIns="36576" bIns="36576" anchor="t">
-            <a:spAutoFit/>
-          </a:bodyPr>
-          <a:lstStyle/>
-          <a:p>
-            <a:pPr algn="l"/>
-            <a:r>
-              <a:rPr sz="1500" b="0">
-                <a:solidFill>
-                  <a:srgbClr val="8B949E"/>
-                </a:solidFill>
-                <a:latin typeface="Aptos"/>
-              </a:rPr>
-              <a:t>Key on lockfiles; restore broadly; measure hit rate.</a:t>
-            </a:r>
-          </a:p>
-        </p:txBody>
-      </p:sp>
-      <p:sp>
-        <p:nvSpPr>
-          <p:cNvPr id="14" name="Rounded Rectangle 13"/>
-          <p:cNvSpPr/>
-          <p:nvPr/>
-        </p:nvSpPr>
-        <p:spPr>
-          <a:xfrm>
-            <a:off x="777240" y="3438144"/>
-            <a:ext cx="530352" cy="530352"/>
-          </a:xfrm>
-          <a:prstGeom prst="roundRect">
-            <a:avLst/>
-          </a:prstGeom>
-          <a:solidFill>
-            <a:srgbClr val="3FB950"/>
-          </a:solidFill>
-          <a:ln>
-            <a:solidFill>
-              <a:srgbClr val="3FB950"/>
-            </a:solidFill>
-          </a:ln>
-        </p:spPr>
-        <p:style>
-          <a:lnRef idx="1">
-            <a:schemeClr val="accent1"/>
-          </a:lnRef>
-          <a:fillRef idx="3">
-            <a:schemeClr val="accent1"/>
-          </a:fillRef>
-          <a:effectRef idx="2">
-            <a:schemeClr val="accent1"/>
-          </a:effectRef>
-          <a:fontRef idx="minor">
-            <a:schemeClr val="lt1"/>
-          </a:fontRef>
-        </p:style>
-        <p:txBody>
-          <a:bodyPr rtlCol="0" anchor="ctr"/>
-          <a:lstStyle/>
-          <a:p>
-            <a:pPr algn="ctr"/>
-          </a:p>
-        </p:txBody>
-      </p:sp>
-      <p:sp>
-        <p:nvSpPr>
-          <p:cNvPr id="15" name="TextBox 14"/>
-          <p:cNvSpPr txBox="1"/>
-          <p:nvPr/>
-        </p:nvSpPr>
-        <p:spPr>
-          <a:xfrm>
-            <a:off x="777240" y="3566160"/>
-            <a:ext cx="530352" cy="219456"/>
-          </a:xfrm>
-          <a:prstGeom prst="rect">
-            <a:avLst/>
-          </a:prstGeom>
-          <a:noFill/>
-        </p:spPr>
-        <p:txBody>
-          <a:bodyPr wrap="square" lIns="36576" rIns="36576" tIns="36576" bIns="36576" anchor="t">
-            <a:spAutoFit/>
-          </a:bodyPr>
-          <a:lstStyle/>
-          <a:p>
-            <a:pPr algn="ctr"/>
-            <a:r>
-              <a:rPr sz="1300" b="1">
-                <a:solidFill>
-                  <a:srgbClr val="0D1117"/>
-                </a:solidFill>
-                <a:latin typeface="Aptos"/>
-              </a:rPr>
-              <a:t>3</a:t>
-            </a:r>
-          </a:p>
-        </p:txBody>
-      </p:sp>
-      <p:sp>
-        <p:nvSpPr>
-          <p:cNvPr id="16" name="TextBox 15"/>
-          <p:cNvSpPr txBox="1"/>
-          <p:nvPr/>
-        </p:nvSpPr>
-        <p:spPr>
-          <a:xfrm>
-            <a:off x="1536192" y="3429000"/>
-            <a:ext cx="2560320" cy="310896"/>
-          </a:xfrm>
-          <a:prstGeom prst="rect">
-            <a:avLst/>
-          </a:prstGeom>
-          <a:noFill/>
-        </p:spPr>
-        <p:txBody>
-          <a:bodyPr wrap="square" lIns="36576" rIns="36576" tIns="36576" bIns="36576" anchor="t">
-            <a:spAutoFit/>
-          </a:bodyPr>
-          <a:lstStyle/>
-          <a:p>
-            <a:pPr algn="l"/>
-            <a:r>
-              <a:rPr sz="1800" b="1">
-                <a:solidFill>
-                  <a:srgbClr val="F0F6FC"/>
-                </a:solidFill>
-                <a:latin typeface="Aptos"/>
-              </a:rPr>
-              <a:t>Filter early</a:t>
-            </a:r>
-          </a:p>
-        </p:txBody>
-      </p:sp>
-      <p:sp>
-        <p:nvSpPr>
-          <p:cNvPr id="17" name="TextBox 16"/>
-          <p:cNvSpPr txBox="1"/>
-          <p:nvPr/>
-        </p:nvSpPr>
-        <p:spPr>
-          <a:xfrm>
-            <a:off x="3886200" y="3456432"/>
-            <a:ext cx="7223760" cy="292608"/>
-          </a:xfrm>
-          <a:prstGeom prst="rect">
-            <a:avLst/>
-          </a:prstGeom>
-          <a:noFill/>
-        </p:spPr>
-        <p:txBody>
-          <a:bodyPr wrap="square" lIns="36576" rIns="36576" tIns="36576" bIns="36576" anchor="t">
-            <a:spAutoFit/>
-          </a:bodyPr>
-          <a:lstStyle/>
-          <a:p>
-            <a:pPr algn="l"/>
-            <a:r>
-              <a:rPr sz="1500" b="0">
-                <a:solidFill>
-                  <a:srgbClr val="8B949E"/>
-                </a:solidFill>
-                <a:latin typeface="Aptos"/>
-              </a:rPr>
-              <a:t>Use paths, branches, and job if conditions before runners start.</a:t>
-            </a:r>
-          </a:p>
-        </p:txBody>
-      </p:sp>
-      <p:sp>
-        <p:nvSpPr>
-          <p:cNvPr id="18" name="Rounded Rectangle 17"/>
-          <p:cNvSpPr/>
-          <p:nvPr/>
-        </p:nvSpPr>
-        <p:spPr>
-          <a:xfrm>
-            <a:off x="777240" y="4306824"/>
-            <a:ext cx="530352" cy="530352"/>
-          </a:xfrm>
-          <a:prstGeom prst="roundRect">
-            <a:avLst/>
-          </a:prstGeom>
-          <a:solidFill>
-            <a:srgbClr val="D29922"/>
-          </a:solidFill>
-          <a:ln>
-            <a:solidFill>
-              <a:srgbClr val="D29922"/>
-            </a:solidFill>
-          </a:ln>
-        </p:spPr>
-        <p:style>
-          <a:lnRef idx="1">
-            <a:schemeClr val="accent1"/>
-          </a:lnRef>
-          <a:fillRef idx="3">
-            <a:schemeClr val="accent1"/>
-          </a:fillRef>
-          <a:effectRef idx="2">
-            <a:schemeClr val="accent1"/>
-          </a:effectRef>
-          <a:fontRef idx="minor">
-            <a:schemeClr val="lt1"/>
-          </a:fontRef>
-        </p:style>
-        <p:txBody>
-          <a:bodyPr rtlCol="0" anchor="ctr"/>
-          <a:lstStyle/>
-          <a:p>
-            <a:pPr algn="ctr"/>
+              <a:rPr sz="1900" b="1">
+                <a:solidFill>
+                  <a:srgbClr val="3FB950"/>
+                </a:solidFill>
+                <a:latin typeface="Aptos"/>
+              </a:rPr>
+              <a:t>Land the point: quality and security are now independently reportable.</a:t>
+            </a:r>
           </a:p>
         </p:txBody>
       </p:sp>
       <p:sp>
         <p:nvSpPr>
           <p:cNvPr id="19" name="TextBox 18"/>
-          <p:cNvSpPr txBox="1"/>
-          <p:nvPr/>
-        </p:nvSpPr>
-        <p:spPr>
-          <a:xfrm>
-            <a:off x="777240" y="4434840"/>
-            <a:ext cx="530352" cy="219456"/>
-          </a:xfrm>
-          <a:prstGeom prst="rect">
-            <a:avLst/>
-          </a:prstGeom>
-          <a:noFill/>
-        </p:spPr>
-        <p:txBody>
-          <a:bodyPr wrap="square" lIns="36576" rIns="36576" tIns="36576" bIns="36576" anchor="t">
-            <a:spAutoFit/>
-          </a:bodyPr>
-          <a:lstStyle/>
-          <a:p>
-            <a:pPr algn="ctr"/>
-            <a:r>
-              <a:rPr sz="1300" b="1">
-                <a:solidFill>
-                  <a:srgbClr val="0D1117"/>
-                </a:solidFill>
-                <a:latin typeface="Aptos"/>
-              </a:rPr>
-              <a:t>4</a:t>
-            </a:r>
-          </a:p>
-        </p:txBody>
-      </p:sp>
-      <p:sp>
-        <p:nvSpPr>
-          <p:cNvPr id="20" name="TextBox 19"/>
-          <p:cNvSpPr txBox="1"/>
-          <p:nvPr/>
-        </p:nvSpPr>
-        <p:spPr>
-          <a:xfrm>
-            <a:off x="1536192" y="4297680"/>
-            <a:ext cx="2560320" cy="310896"/>
-          </a:xfrm>
-          <a:prstGeom prst="rect">
-            <a:avLst/>
-          </a:prstGeom>
-          <a:noFill/>
-        </p:spPr>
-        <p:txBody>
-          <a:bodyPr wrap="square" lIns="36576" rIns="36576" tIns="36576" bIns="36576" anchor="t">
-            <a:spAutoFit/>
-          </a:bodyPr>
-          <a:lstStyle/>
-          <a:p>
-            <a:pPr algn="l"/>
-            <a:r>
-              <a:rPr sz="1800" b="1">
-                <a:solidFill>
-                  <a:srgbClr val="F0F6FC"/>
-                </a:solidFill>
-                <a:latin typeface="Aptos"/>
-              </a:rPr>
-              <a:t>Shrink the matrix</a:t>
-            </a:r>
-          </a:p>
-        </p:txBody>
-      </p:sp>
-      <p:sp>
-        <p:nvSpPr>
-          <p:cNvPr id="21" name="TextBox 20"/>
-          <p:cNvSpPr txBox="1"/>
-          <p:nvPr/>
-        </p:nvSpPr>
-        <p:spPr>
-          <a:xfrm>
-            <a:off x="3886200" y="4325112"/>
-            <a:ext cx="7223760" cy="292608"/>
-          </a:xfrm>
-          <a:prstGeom prst="rect">
-            <a:avLst/>
-          </a:prstGeom>
-          <a:noFill/>
-        </p:spPr>
-        <p:txBody>
-          <a:bodyPr wrap="square" lIns="36576" rIns="36576" tIns="36576" bIns="36576" anchor="t">
-            <a:spAutoFit/>
-          </a:bodyPr>
-          <a:lstStyle/>
-          <a:p>
-            <a:pPr algn="l"/>
-            <a:r>
-              <a:rPr sz="1500" b="0">
-                <a:solidFill>
-                  <a:srgbClr val="8B949E"/>
-                </a:solidFill>
-                <a:latin typeface="Aptos"/>
-              </a:rPr>
-              <a:t>Test representative combinations first; expand on main or nightly.</a:t>
-            </a:r>
-          </a:p>
-        </p:txBody>
-      </p:sp>
-      <p:sp>
-        <p:nvSpPr>
-          <p:cNvPr id="22" name="Rounded Rectangle 21"/>
-          <p:cNvSpPr/>
-          <p:nvPr/>
-        </p:nvSpPr>
-        <p:spPr>
-          <a:xfrm>
-            <a:off x="777240" y="5175504"/>
-            <a:ext cx="530352" cy="530352"/>
-          </a:xfrm>
-          <a:prstGeom prst="roundRect">
-            <a:avLst/>
-          </a:prstGeom>
-          <a:solidFill>
-            <a:srgbClr val="F85149"/>
-          </a:solidFill>
-          <a:ln>
-            <a:solidFill>
-              <a:srgbClr val="F85149"/>
-            </a:solidFill>
-          </a:ln>
-        </p:spPr>
-        <p:style>
-          <a:lnRef idx="1">
-            <a:schemeClr val="accent1"/>
-          </a:lnRef>
-          <a:fillRef idx="3">
-            <a:schemeClr val="accent1"/>
-          </a:fillRef>
-          <a:effectRef idx="2">
-            <a:schemeClr val="accent1"/>
-          </a:effectRef>
-          <a:fontRef idx="minor">
-            <a:schemeClr val="lt1"/>
-          </a:fontRef>
-        </p:style>
-        <p:txBody>
-          <a:bodyPr rtlCol="0" anchor="ctr"/>
-          <a:lstStyle/>
-          <a:p>
-            <a:pPr algn="ctr"/>
-          </a:p>
-        </p:txBody>
-      </p:sp>
-      <p:sp>
-        <p:nvSpPr>
-          <p:cNvPr id="23" name="TextBox 22"/>
-          <p:cNvSpPr txBox="1"/>
-          <p:nvPr/>
-        </p:nvSpPr>
-        <p:spPr>
-          <a:xfrm>
-            <a:off x="777240" y="5303520"/>
-            <a:ext cx="530352" cy="219456"/>
-          </a:xfrm>
-          <a:prstGeom prst="rect">
-            <a:avLst/>
-          </a:prstGeom>
-          <a:noFill/>
-        </p:spPr>
-        <p:txBody>
-          <a:bodyPr wrap="square" lIns="36576" rIns="36576" tIns="36576" bIns="36576" anchor="t">
-            <a:spAutoFit/>
-          </a:bodyPr>
-          <a:lstStyle/>
-          <a:p>
-            <a:pPr algn="ctr"/>
-            <a:r>
-              <a:rPr sz="1300" b="1">
-                <a:solidFill>
-                  <a:srgbClr val="0D1117"/>
-                </a:solidFill>
-                <a:latin typeface="Aptos"/>
-              </a:rPr>
-              <a:t>5</a:t>
-            </a:r>
-          </a:p>
-        </p:txBody>
-      </p:sp>
-      <p:sp>
-        <p:nvSpPr>
-          <p:cNvPr id="24" name="TextBox 23"/>
-          <p:cNvSpPr txBox="1"/>
-          <p:nvPr/>
-        </p:nvSpPr>
-        <p:spPr>
-          <a:xfrm>
-            <a:off x="1536192" y="5166360"/>
-            <a:ext cx="2560320" cy="310896"/>
-          </a:xfrm>
-          <a:prstGeom prst="rect">
-            <a:avLst/>
-          </a:prstGeom>
-          <a:noFill/>
-        </p:spPr>
-        <p:txBody>
-          <a:bodyPr wrap="square" lIns="36576" rIns="36576" tIns="36576" bIns="36576" anchor="t">
-            <a:spAutoFit/>
-          </a:bodyPr>
-          <a:lstStyle/>
-          <a:p>
-            <a:pPr algn="l"/>
-            <a:r>
-              <a:rPr sz="1800" b="1">
-                <a:solidFill>
-                  <a:srgbClr val="F0F6FC"/>
-                </a:solidFill>
-                <a:latin typeface="Aptos"/>
-              </a:rPr>
-              <a:t>Measure the queue</a:t>
-            </a:r>
-          </a:p>
-        </p:txBody>
-      </p:sp>
-      <p:sp>
-        <p:nvSpPr>
-          <p:cNvPr id="25" name="TextBox 24"/>
-          <p:cNvSpPr txBox="1"/>
-          <p:nvPr/>
-        </p:nvSpPr>
-        <p:spPr>
-          <a:xfrm>
-            <a:off x="3886200" y="5193792"/>
-            <a:ext cx="7223760" cy="292608"/>
-          </a:xfrm>
-          <a:prstGeom prst="rect">
-            <a:avLst/>
-          </a:prstGeom>
-          <a:noFill/>
-        </p:spPr>
-        <p:txBody>
-          <a:bodyPr wrap="square" lIns="36576" rIns="36576" tIns="36576" bIns="36576" anchor="t">
-            <a:spAutoFit/>
-          </a:bodyPr>
-          <a:lstStyle/>
-          <a:p>
-            <a:pPr algn="l"/>
-            <a:r>
-              <a:rPr sz="1500" b="0">
-                <a:solidFill>
-                  <a:srgbClr val="8B949E"/>
-                </a:solidFill>
-                <a:latin typeface="Aptos"/>
-              </a:rPr>
-              <a:t>Separate queue time from execution time before changing code.</a:t>
-            </a:r>
-          </a:p>
-        </p:txBody>
-      </p:sp>
-      <p:sp>
-        <p:nvSpPr>
-          <p:cNvPr id="26" name="Rounded Rectangle 25"/>
-          <p:cNvSpPr/>
-          <p:nvPr/>
-        </p:nvSpPr>
-        <p:spPr>
-          <a:xfrm>
-            <a:off x="777240" y="6062472"/>
-            <a:ext cx="10561320" cy="384048"/>
-          </a:xfrm>
-          <a:prstGeom prst="roundRect">
-            <a:avLst/>
-          </a:prstGeom>
-          <a:solidFill>
-            <a:srgbClr val="21262D"/>
-          </a:solidFill>
-          <a:ln>
-            <a:solidFill>
-              <a:srgbClr val="21262D"/>
-            </a:solidFill>
-          </a:ln>
-        </p:spPr>
-        <p:style>
-          <a:lnRef idx="1">
-            <a:schemeClr val="accent1"/>
-          </a:lnRef>
-          <a:fillRef idx="3">
-            <a:schemeClr val="accent1"/>
-          </a:fillRef>
-          <a:effectRef idx="2">
-            <a:schemeClr val="accent1"/>
-          </a:effectRef>
-          <a:fontRef idx="minor">
-            <a:schemeClr val="lt1"/>
-          </a:fontRef>
-        </p:style>
-        <p:txBody>
-          <a:bodyPr rtlCol="0" anchor="ctr"/>
-          <a:lstStyle/>
-          <a:p>
-            <a:pPr algn="ctr"/>
-          </a:p>
-        </p:txBody>
-      </p:sp>
-      <p:sp>
-        <p:nvSpPr>
-          <p:cNvPr id="27" name="TextBox 26"/>
-          <p:cNvSpPr txBox="1"/>
-          <p:nvPr/>
-        </p:nvSpPr>
-        <p:spPr>
-          <a:xfrm>
-            <a:off x="777240" y="6153912"/>
-            <a:ext cx="10561320" cy="201168"/>
-          </a:xfrm>
-          <a:prstGeom prst="rect">
-            <a:avLst/>
-          </a:prstGeom>
-          <a:noFill/>
-        </p:spPr>
-        <p:txBody>
-          <a:bodyPr wrap="square" lIns="36576" rIns="36576" tIns="36576" bIns="36576" anchor="t">
-            <a:spAutoFit/>
-          </a:bodyPr>
-          <a:lstStyle/>
-          <a:p>
-            <a:pPr algn="ctr"/>
-            <a:r>
-              <a:rPr sz="1300" b="1">
-                <a:solidFill>
-                  <a:srgbClr val="F0F6FC"/>
-                </a:solidFill>
-                <a:latin typeface="Aptos"/>
-              </a:rPr>
-              <a:t>Optimize total feedback time—not just step duration.</a:t>
-            </a:r>
-          </a:p>
-        </p:txBody>
-      </p:sp>
-      <p:sp>
-        <p:nvSpPr>
-          <p:cNvPr id="28" name="TextBox 27"/>
           <p:cNvSpPr txBox="1"/>
           <p:nvPr/>
         </p:nvSpPr>
@@ -11677,7 +11855,7 @@
                 </a:solidFill>
                 <a:latin typeface="Aptos"/>
               </a:rPr>
-              <a:t>CLOSE</a:t>
+              <a:t>FINAL FIVE MINUTES</a:t>
             </a:r>
           </a:p>
         </p:txBody>
@@ -11712,7 +11890,7 @@
                 </a:solidFill>
                 <a:latin typeface="Aptos"/>
               </a:rPr>
-              <a:t>Three actions for next week</a:t>
+              <a:t>Five performance moves with outsized returns</a:t>
             </a:r>
           </a:p>
         </p:txBody>
@@ -11805,6 +11983,1047 @@
         </p:nvSpPr>
         <p:spPr>
           <a:xfrm>
+            <a:off x="777240" y="1700784"/>
+            <a:ext cx="530352" cy="530352"/>
+          </a:xfrm>
+          <a:prstGeom prst="roundRect">
+            <a:avLst/>
+          </a:prstGeom>
+          <a:solidFill>
+            <a:srgbClr val="58A6FF"/>
+          </a:solidFill>
+          <a:ln>
+            <a:solidFill>
+              <a:srgbClr val="58A6FF"/>
+            </a:solidFill>
+          </a:ln>
+        </p:spPr>
+        <p:style>
+          <a:lnRef idx="1">
+            <a:schemeClr val="accent1"/>
+          </a:lnRef>
+          <a:fillRef idx="3">
+            <a:schemeClr val="accent1"/>
+          </a:fillRef>
+          <a:effectRef idx="2">
+            <a:schemeClr val="accent1"/>
+          </a:effectRef>
+          <a:fontRef idx="minor">
+            <a:schemeClr val="lt1"/>
+          </a:fontRef>
+        </p:style>
+        <p:txBody>
+          <a:bodyPr rtlCol="0" anchor="ctr"/>
+          <a:lstStyle/>
+          <a:p>
+            <a:pPr algn="ctr"/>
+          </a:p>
+        </p:txBody>
+      </p:sp>
+      <p:sp>
+        <p:nvSpPr>
+          <p:cNvPr id="7" name="TextBox 6"/>
+          <p:cNvSpPr txBox="1"/>
+          <p:nvPr/>
+        </p:nvSpPr>
+        <p:spPr>
+          <a:xfrm>
+            <a:off x="777240" y="1828800"/>
+            <a:ext cx="530352" cy="219456"/>
+          </a:xfrm>
+          <a:prstGeom prst="rect">
+            <a:avLst/>
+          </a:prstGeom>
+          <a:noFill/>
+        </p:spPr>
+        <p:txBody>
+          <a:bodyPr wrap="square" lIns="36576" rIns="36576" tIns="36576" bIns="36576" anchor="t">
+            <a:spAutoFit/>
+          </a:bodyPr>
+          <a:lstStyle/>
+          <a:p>
+            <a:pPr algn="ctr"/>
+            <a:r>
+              <a:rPr sz="1300" b="1">
+                <a:solidFill>
+                  <a:srgbClr val="0D1117"/>
+                </a:solidFill>
+                <a:latin typeface="Aptos"/>
+              </a:rPr>
+              <a:t>1</a:t>
+            </a:r>
+          </a:p>
+        </p:txBody>
+      </p:sp>
+      <p:sp>
+        <p:nvSpPr>
+          <p:cNvPr id="8" name="TextBox 7"/>
+          <p:cNvSpPr txBox="1"/>
+          <p:nvPr/>
+        </p:nvSpPr>
+        <p:spPr>
+          <a:xfrm>
+            <a:off x="1536192" y="1691640"/>
+            <a:ext cx="2560320" cy="310896"/>
+          </a:xfrm>
+          <a:prstGeom prst="rect">
+            <a:avLst/>
+          </a:prstGeom>
+          <a:noFill/>
+        </p:spPr>
+        <p:txBody>
+          <a:bodyPr wrap="square" lIns="36576" rIns="36576" tIns="36576" bIns="36576" anchor="t">
+            <a:spAutoFit/>
+          </a:bodyPr>
+          <a:lstStyle/>
+          <a:p>
+            <a:pPr algn="l"/>
+            <a:r>
+              <a:rPr sz="1800" b="1">
+                <a:solidFill>
+                  <a:srgbClr val="F0F6FC"/>
+                </a:solidFill>
+                <a:latin typeface="Aptos"/>
+              </a:rPr>
+              <a:t>Cancel stale work</a:t>
+            </a:r>
+          </a:p>
+        </p:txBody>
+      </p:sp>
+      <p:sp>
+        <p:nvSpPr>
+          <p:cNvPr id="9" name="TextBox 8"/>
+          <p:cNvSpPr txBox="1"/>
+          <p:nvPr/>
+        </p:nvSpPr>
+        <p:spPr>
+          <a:xfrm>
+            <a:off x="3886200" y="1719072"/>
+            <a:ext cx="7223760" cy="292608"/>
+          </a:xfrm>
+          <a:prstGeom prst="rect">
+            <a:avLst/>
+          </a:prstGeom>
+          <a:noFill/>
+        </p:spPr>
+        <p:txBody>
+          <a:bodyPr wrap="square" lIns="36576" rIns="36576" tIns="36576" bIns="36576" anchor="t">
+            <a:spAutoFit/>
+          </a:bodyPr>
+          <a:lstStyle/>
+          <a:p>
+            <a:pPr algn="l"/>
+            <a:r>
+              <a:rPr sz="1500" b="0">
+                <a:solidFill>
+                  <a:srgbClr val="8B949E"/>
+                </a:solidFill>
+                <a:latin typeface="Aptos"/>
+              </a:rPr>
+              <a:t>Use concurrency groups with cancel-in-progress for PRs.</a:t>
+            </a:r>
+          </a:p>
+        </p:txBody>
+      </p:sp>
+      <p:sp>
+        <p:nvSpPr>
+          <p:cNvPr id="10" name="Rounded Rectangle 9"/>
+          <p:cNvSpPr/>
+          <p:nvPr/>
+        </p:nvSpPr>
+        <p:spPr>
+          <a:xfrm>
+            <a:off x="777240" y="2569464"/>
+            <a:ext cx="530352" cy="530352"/>
+          </a:xfrm>
+          <a:prstGeom prst="roundRect">
+            <a:avLst/>
+          </a:prstGeom>
+          <a:solidFill>
+            <a:srgbClr val="BC8CFF"/>
+          </a:solidFill>
+          <a:ln>
+            <a:solidFill>
+              <a:srgbClr val="BC8CFF"/>
+            </a:solidFill>
+          </a:ln>
+        </p:spPr>
+        <p:style>
+          <a:lnRef idx="1">
+            <a:schemeClr val="accent1"/>
+          </a:lnRef>
+          <a:fillRef idx="3">
+            <a:schemeClr val="accent1"/>
+          </a:fillRef>
+          <a:effectRef idx="2">
+            <a:schemeClr val="accent1"/>
+          </a:effectRef>
+          <a:fontRef idx="minor">
+            <a:schemeClr val="lt1"/>
+          </a:fontRef>
+        </p:style>
+        <p:txBody>
+          <a:bodyPr rtlCol="0" anchor="ctr"/>
+          <a:lstStyle/>
+          <a:p>
+            <a:pPr algn="ctr"/>
+          </a:p>
+        </p:txBody>
+      </p:sp>
+      <p:sp>
+        <p:nvSpPr>
+          <p:cNvPr id="11" name="TextBox 10"/>
+          <p:cNvSpPr txBox="1"/>
+          <p:nvPr/>
+        </p:nvSpPr>
+        <p:spPr>
+          <a:xfrm>
+            <a:off x="777240" y="2697480"/>
+            <a:ext cx="530352" cy="219456"/>
+          </a:xfrm>
+          <a:prstGeom prst="rect">
+            <a:avLst/>
+          </a:prstGeom>
+          <a:noFill/>
+        </p:spPr>
+        <p:txBody>
+          <a:bodyPr wrap="square" lIns="36576" rIns="36576" tIns="36576" bIns="36576" anchor="t">
+            <a:spAutoFit/>
+          </a:bodyPr>
+          <a:lstStyle/>
+          <a:p>
+            <a:pPr algn="ctr"/>
+            <a:r>
+              <a:rPr sz="1300" b="1">
+                <a:solidFill>
+                  <a:srgbClr val="0D1117"/>
+                </a:solidFill>
+                <a:latin typeface="Aptos"/>
+              </a:rPr>
+              <a:t>2</a:t>
+            </a:r>
+          </a:p>
+        </p:txBody>
+      </p:sp>
+      <p:sp>
+        <p:nvSpPr>
+          <p:cNvPr id="12" name="TextBox 11"/>
+          <p:cNvSpPr txBox="1"/>
+          <p:nvPr/>
+        </p:nvSpPr>
+        <p:spPr>
+          <a:xfrm>
+            <a:off x="1536192" y="2560320"/>
+            <a:ext cx="2560320" cy="310896"/>
+          </a:xfrm>
+          <a:prstGeom prst="rect">
+            <a:avLst/>
+          </a:prstGeom>
+          <a:noFill/>
+        </p:spPr>
+        <p:txBody>
+          <a:bodyPr wrap="square" lIns="36576" rIns="36576" tIns="36576" bIns="36576" anchor="t">
+            <a:spAutoFit/>
+          </a:bodyPr>
+          <a:lstStyle/>
+          <a:p>
+            <a:pPr algn="l"/>
+            <a:r>
+              <a:rPr sz="1800" b="1">
+                <a:solidFill>
+                  <a:srgbClr val="F0F6FC"/>
+                </a:solidFill>
+                <a:latin typeface="Aptos"/>
+              </a:rPr>
+              <a:t>Cache with intent</a:t>
+            </a:r>
+          </a:p>
+        </p:txBody>
+      </p:sp>
+      <p:sp>
+        <p:nvSpPr>
+          <p:cNvPr id="13" name="TextBox 12"/>
+          <p:cNvSpPr txBox="1"/>
+          <p:nvPr/>
+        </p:nvSpPr>
+        <p:spPr>
+          <a:xfrm>
+            <a:off x="3886200" y="2587752"/>
+            <a:ext cx="7223760" cy="292608"/>
+          </a:xfrm>
+          <a:prstGeom prst="rect">
+            <a:avLst/>
+          </a:prstGeom>
+          <a:noFill/>
+        </p:spPr>
+        <p:txBody>
+          <a:bodyPr wrap="square" lIns="36576" rIns="36576" tIns="36576" bIns="36576" anchor="t">
+            <a:spAutoFit/>
+          </a:bodyPr>
+          <a:lstStyle/>
+          <a:p>
+            <a:pPr algn="l"/>
+            <a:r>
+              <a:rPr sz="1500" b="0">
+                <a:solidFill>
+                  <a:srgbClr val="8B949E"/>
+                </a:solidFill>
+                <a:latin typeface="Aptos"/>
+              </a:rPr>
+              <a:t>Key on lockfiles; restore broadly; measure hit rate.</a:t>
+            </a:r>
+          </a:p>
+        </p:txBody>
+      </p:sp>
+      <p:sp>
+        <p:nvSpPr>
+          <p:cNvPr id="14" name="Rounded Rectangle 13"/>
+          <p:cNvSpPr/>
+          <p:nvPr/>
+        </p:nvSpPr>
+        <p:spPr>
+          <a:xfrm>
+            <a:off x="777240" y="3438144"/>
+            <a:ext cx="530352" cy="530352"/>
+          </a:xfrm>
+          <a:prstGeom prst="roundRect">
+            <a:avLst/>
+          </a:prstGeom>
+          <a:solidFill>
+            <a:srgbClr val="3FB950"/>
+          </a:solidFill>
+          <a:ln>
+            <a:solidFill>
+              <a:srgbClr val="3FB950"/>
+            </a:solidFill>
+          </a:ln>
+        </p:spPr>
+        <p:style>
+          <a:lnRef idx="1">
+            <a:schemeClr val="accent1"/>
+          </a:lnRef>
+          <a:fillRef idx="3">
+            <a:schemeClr val="accent1"/>
+          </a:fillRef>
+          <a:effectRef idx="2">
+            <a:schemeClr val="accent1"/>
+          </a:effectRef>
+          <a:fontRef idx="minor">
+            <a:schemeClr val="lt1"/>
+          </a:fontRef>
+        </p:style>
+        <p:txBody>
+          <a:bodyPr rtlCol="0" anchor="ctr"/>
+          <a:lstStyle/>
+          <a:p>
+            <a:pPr algn="ctr"/>
+          </a:p>
+        </p:txBody>
+      </p:sp>
+      <p:sp>
+        <p:nvSpPr>
+          <p:cNvPr id="15" name="TextBox 14"/>
+          <p:cNvSpPr txBox="1"/>
+          <p:nvPr/>
+        </p:nvSpPr>
+        <p:spPr>
+          <a:xfrm>
+            <a:off x="777240" y="3566160"/>
+            <a:ext cx="530352" cy="219456"/>
+          </a:xfrm>
+          <a:prstGeom prst="rect">
+            <a:avLst/>
+          </a:prstGeom>
+          <a:noFill/>
+        </p:spPr>
+        <p:txBody>
+          <a:bodyPr wrap="square" lIns="36576" rIns="36576" tIns="36576" bIns="36576" anchor="t">
+            <a:spAutoFit/>
+          </a:bodyPr>
+          <a:lstStyle/>
+          <a:p>
+            <a:pPr algn="ctr"/>
+            <a:r>
+              <a:rPr sz="1300" b="1">
+                <a:solidFill>
+                  <a:srgbClr val="0D1117"/>
+                </a:solidFill>
+                <a:latin typeface="Aptos"/>
+              </a:rPr>
+              <a:t>3</a:t>
+            </a:r>
+          </a:p>
+        </p:txBody>
+      </p:sp>
+      <p:sp>
+        <p:nvSpPr>
+          <p:cNvPr id="16" name="TextBox 15"/>
+          <p:cNvSpPr txBox="1"/>
+          <p:nvPr/>
+        </p:nvSpPr>
+        <p:spPr>
+          <a:xfrm>
+            <a:off x="1536192" y="3429000"/>
+            <a:ext cx="2560320" cy="310896"/>
+          </a:xfrm>
+          <a:prstGeom prst="rect">
+            <a:avLst/>
+          </a:prstGeom>
+          <a:noFill/>
+        </p:spPr>
+        <p:txBody>
+          <a:bodyPr wrap="square" lIns="36576" rIns="36576" tIns="36576" bIns="36576" anchor="t">
+            <a:spAutoFit/>
+          </a:bodyPr>
+          <a:lstStyle/>
+          <a:p>
+            <a:pPr algn="l"/>
+            <a:r>
+              <a:rPr sz="1800" b="1">
+                <a:solidFill>
+                  <a:srgbClr val="F0F6FC"/>
+                </a:solidFill>
+                <a:latin typeface="Aptos"/>
+              </a:rPr>
+              <a:t>Filter early</a:t>
+            </a:r>
+          </a:p>
+        </p:txBody>
+      </p:sp>
+      <p:sp>
+        <p:nvSpPr>
+          <p:cNvPr id="17" name="TextBox 16"/>
+          <p:cNvSpPr txBox="1"/>
+          <p:nvPr/>
+        </p:nvSpPr>
+        <p:spPr>
+          <a:xfrm>
+            <a:off x="3886200" y="3456432"/>
+            <a:ext cx="7223760" cy="292608"/>
+          </a:xfrm>
+          <a:prstGeom prst="rect">
+            <a:avLst/>
+          </a:prstGeom>
+          <a:noFill/>
+        </p:spPr>
+        <p:txBody>
+          <a:bodyPr wrap="square" lIns="36576" rIns="36576" tIns="36576" bIns="36576" anchor="t">
+            <a:spAutoFit/>
+          </a:bodyPr>
+          <a:lstStyle/>
+          <a:p>
+            <a:pPr algn="l"/>
+            <a:r>
+              <a:rPr sz="1500" b="0">
+                <a:solidFill>
+                  <a:srgbClr val="8B949E"/>
+                </a:solidFill>
+                <a:latin typeface="Aptos"/>
+              </a:rPr>
+              <a:t>Use paths, branches, and job if conditions before runners start.</a:t>
+            </a:r>
+          </a:p>
+        </p:txBody>
+      </p:sp>
+      <p:sp>
+        <p:nvSpPr>
+          <p:cNvPr id="18" name="Rounded Rectangle 17"/>
+          <p:cNvSpPr/>
+          <p:nvPr/>
+        </p:nvSpPr>
+        <p:spPr>
+          <a:xfrm>
+            <a:off x="777240" y="4306824"/>
+            <a:ext cx="530352" cy="530352"/>
+          </a:xfrm>
+          <a:prstGeom prst="roundRect">
+            <a:avLst/>
+          </a:prstGeom>
+          <a:solidFill>
+            <a:srgbClr val="D29922"/>
+          </a:solidFill>
+          <a:ln>
+            <a:solidFill>
+              <a:srgbClr val="D29922"/>
+            </a:solidFill>
+          </a:ln>
+        </p:spPr>
+        <p:style>
+          <a:lnRef idx="1">
+            <a:schemeClr val="accent1"/>
+          </a:lnRef>
+          <a:fillRef idx="3">
+            <a:schemeClr val="accent1"/>
+          </a:fillRef>
+          <a:effectRef idx="2">
+            <a:schemeClr val="accent1"/>
+          </a:effectRef>
+          <a:fontRef idx="minor">
+            <a:schemeClr val="lt1"/>
+          </a:fontRef>
+        </p:style>
+        <p:txBody>
+          <a:bodyPr rtlCol="0" anchor="ctr"/>
+          <a:lstStyle/>
+          <a:p>
+            <a:pPr algn="ctr"/>
+          </a:p>
+        </p:txBody>
+      </p:sp>
+      <p:sp>
+        <p:nvSpPr>
+          <p:cNvPr id="19" name="TextBox 18"/>
+          <p:cNvSpPr txBox="1"/>
+          <p:nvPr/>
+        </p:nvSpPr>
+        <p:spPr>
+          <a:xfrm>
+            <a:off x="777240" y="4434840"/>
+            <a:ext cx="530352" cy="219456"/>
+          </a:xfrm>
+          <a:prstGeom prst="rect">
+            <a:avLst/>
+          </a:prstGeom>
+          <a:noFill/>
+        </p:spPr>
+        <p:txBody>
+          <a:bodyPr wrap="square" lIns="36576" rIns="36576" tIns="36576" bIns="36576" anchor="t">
+            <a:spAutoFit/>
+          </a:bodyPr>
+          <a:lstStyle/>
+          <a:p>
+            <a:pPr algn="ctr"/>
+            <a:r>
+              <a:rPr sz="1300" b="1">
+                <a:solidFill>
+                  <a:srgbClr val="0D1117"/>
+                </a:solidFill>
+                <a:latin typeface="Aptos"/>
+              </a:rPr>
+              <a:t>4</a:t>
+            </a:r>
+          </a:p>
+        </p:txBody>
+      </p:sp>
+      <p:sp>
+        <p:nvSpPr>
+          <p:cNvPr id="20" name="TextBox 19"/>
+          <p:cNvSpPr txBox="1"/>
+          <p:nvPr/>
+        </p:nvSpPr>
+        <p:spPr>
+          <a:xfrm>
+            <a:off x="1536192" y="4297680"/>
+            <a:ext cx="2560320" cy="310896"/>
+          </a:xfrm>
+          <a:prstGeom prst="rect">
+            <a:avLst/>
+          </a:prstGeom>
+          <a:noFill/>
+        </p:spPr>
+        <p:txBody>
+          <a:bodyPr wrap="square" lIns="36576" rIns="36576" tIns="36576" bIns="36576" anchor="t">
+            <a:spAutoFit/>
+          </a:bodyPr>
+          <a:lstStyle/>
+          <a:p>
+            <a:pPr algn="l"/>
+            <a:r>
+              <a:rPr sz="1800" b="1">
+                <a:solidFill>
+                  <a:srgbClr val="F0F6FC"/>
+                </a:solidFill>
+                <a:latin typeface="Aptos"/>
+              </a:rPr>
+              <a:t>Shrink the matrix</a:t>
+            </a:r>
+          </a:p>
+        </p:txBody>
+      </p:sp>
+      <p:sp>
+        <p:nvSpPr>
+          <p:cNvPr id="21" name="TextBox 20"/>
+          <p:cNvSpPr txBox="1"/>
+          <p:nvPr/>
+        </p:nvSpPr>
+        <p:spPr>
+          <a:xfrm>
+            <a:off x="3886200" y="4325112"/>
+            <a:ext cx="7223760" cy="292608"/>
+          </a:xfrm>
+          <a:prstGeom prst="rect">
+            <a:avLst/>
+          </a:prstGeom>
+          <a:noFill/>
+        </p:spPr>
+        <p:txBody>
+          <a:bodyPr wrap="square" lIns="36576" rIns="36576" tIns="36576" bIns="36576" anchor="t">
+            <a:spAutoFit/>
+          </a:bodyPr>
+          <a:lstStyle/>
+          <a:p>
+            <a:pPr algn="l"/>
+            <a:r>
+              <a:rPr sz="1500" b="0">
+                <a:solidFill>
+                  <a:srgbClr val="8B949E"/>
+                </a:solidFill>
+                <a:latin typeface="Aptos"/>
+              </a:rPr>
+              <a:t>Test representative combinations first; expand on main or nightly.</a:t>
+            </a:r>
+          </a:p>
+        </p:txBody>
+      </p:sp>
+      <p:sp>
+        <p:nvSpPr>
+          <p:cNvPr id="22" name="Rounded Rectangle 21"/>
+          <p:cNvSpPr/>
+          <p:nvPr/>
+        </p:nvSpPr>
+        <p:spPr>
+          <a:xfrm>
+            <a:off x="777240" y="5175504"/>
+            <a:ext cx="530352" cy="530352"/>
+          </a:xfrm>
+          <a:prstGeom prst="roundRect">
+            <a:avLst/>
+          </a:prstGeom>
+          <a:solidFill>
+            <a:srgbClr val="F85149"/>
+          </a:solidFill>
+          <a:ln>
+            <a:solidFill>
+              <a:srgbClr val="F85149"/>
+            </a:solidFill>
+          </a:ln>
+        </p:spPr>
+        <p:style>
+          <a:lnRef idx="1">
+            <a:schemeClr val="accent1"/>
+          </a:lnRef>
+          <a:fillRef idx="3">
+            <a:schemeClr val="accent1"/>
+          </a:fillRef>
+          <a:effectRef idx="2">
+            <a:schemeClr val="accent1"/>
+          </a:effectRef>
+          <a:fontRef idx="minor">
+            <a:schemeClr val="lt1"/>
+          </a:fontRef>
+        </p:style>
+        <p:txBody>
+          <a:bodyPr rtlCol="0" anchor="ctr"/>
+          <a:lstStyle/>
+          <a:p>
+            <a:pPr algn="ctr"/>
+          </a:p>
+        </p:txBody>
+      </p:sp>
+      <p:sp>
+        <p:nvSpPr>
+          <p:cNvPr id="23" name="TextBox 22"/>
+          <p:cNvSpPr txBox="1"/>
+          <p:nvPr/>
+        </p:nvSpPr>
+        <p:spPr>
+          <a:xfrm>
+            <a:off x="777240" y="5303520"/>
+            <a:ext cx="530352" cy="219456"/>
+          </a:xfrm>
+          <a:prstGeom prst="rect">
+            <a:avLst/>
+          </a:prstGeom>
+          <a:noFill/>
+        </p:spPr>
+        <p:txBody>
+          <a:bodyPr wrap="square" lIns="36576" rIns="36576" tIns="36576" bIns="36576" anchor="t">
+            <a:spAutoFit/>
+          </a:bodyPr>
+          <a:lstStyle/>
+          <a:p>
+            <a:pPr algn="ctr"/>
+            <a:r>
+              <a:rPr sz="1300" b="1">
+                <a:solidFill>
+                  <a:srgbClr val="0D1117"/>
+                </a:solidFill>
+                <a:latin typeface="Aptos"/>
+              </a:rPr>
+              <a:t>5</a:t>
+            </a:r>
+          </a:p>
+        </p:txBody>
+      </p:sp>
+      <p:sp>
+        <p:nvSpPr>
+          <p:cNvPr id="24" name="TextBox 23"/>
+          <p:cNvSpPr txBox="1"/>
+          <p:nvPr/>
+        </p:nvSpPr>
+        <p:spPr>
+          <a:xfrm>
+            <a:off x="1536192" y="5166360"/>
+            <a:ext cx="2560320" cy="310896"/>
+          </a:xfrm>
+          <a:prstGeom prst="rect">
+            <a:avLst/>
+          </a:prstGeom>
+          <a:noFill/>
+        </p:spPr>
+        <p:txBody>
+          <a:bodyPr wrap="square" lIns="36576" rIns="36576" tIns="36576" bIns="36576" anchor="t">
+            <a:spAutoFit/>
+          </a:bodyPr>
+          <a:lstStyle/>
+          <a:p>
+            <a:pPr algn="l"/>
+            <a:r>
+              <a:rPr sz="1800" b="1">
+                <a:solidFill>
+                  <a:srgbClr val="F0F6FC"/>
+                </a:solidFill>
+                <a:latin typeface="Aptos"/>
+              </a:rPr>
+              <a:t>Measure the queue</a:t>
+            </a:r>
+          </a:p>
+        </p:txBody>
+      </p:sp>
+      <p:sp>
+        <p:nvSpPr>
+          <p:cNvPr id="25" name="TextBox 24"/>
+          <p:cNvSpPr txBox="1"/>
+          <p:nvPr/>
+        </p:nvSpPr>
+        <p:spPr>
+          <a:xfrm>
+            <a:off x="3886200" y="5193792"/>
+            <a:ext cx="7223760" cy="292608"/>
+          </a:xfrm>
+          <a:prstGeom prst="rect">
+            <a:avLst/>
+          </a:prstGeom>
+          <a:noFill/>
+        </p:spPr>
+        <p:txBody>
+          <a:bodyPr wrap="square" lIns="36576" rIns="36576" tIns="36576" bIns="36576" anchor="t">
+            <a:spAutoFit/>
+          </a:bodyPr>
+          <a:lstStyle/>
+          <a:p>
+            <a:pPr algn="l"/>
+            <a:r>
+              <a:rPr sz="1500" b="0">
+                <a:solidFill>
+                  <a:srgbClr val="8B949E"/>
+                </a:solidFill>
+                <a:latin typeface="Aptos"/>
+              </a:rPr>
+              <a:t>Separate queue time from execution time before changing code.</a:t>
+            </a:r>
+          </a:p>
+        </p:txBody>
+      </p:sp>
+      <p:sp>
+        <p:nvSpPr>
+          <p:cNvPr id="26" name="Rounded Rectangle 25"/>
+          <p:cNvSpPr/>
+          <p:nvPr/>
+        </p:nvSpPr>
+        <p:spPr>
+          <a:xfrm>
+            <a:off x="777240" y="6062472"/>
+            <a:ext cx="10561320" cy="384048"/>
+          </a:xfrm>
+          <a:prstGeom prst="roundRect">
+            <a:avLst/>
+          </a:prstGeom>
+          <a:solidFill>
+            <a:srgbClr val="21262D"/>
+          </a:solidFill>
+          <a:ln>
+            <a:solidFill>
+              <a:srgbClr val="21262D"/>
+            </a:solidFill>
+          </a:ln>
+        </p:spPr>
+        <p:style>
+          <a:lnRef idx="1">
+            <a:schemeClr val="accent1"/>
+          </a:lnRef>
+          <a:fillRef idx="3">
+            <a:schemeClr val="accent1"/>
+          </a:fillRef>
+          <a:effectRef idx="2">
+            <a:schemeClr val="accent1"/>
+          </a:effectRef>
+          <a:fontRef idx="minor">
+            <a:schemeClr val="lt1"/>
+          </a:fontRef>
+        </p:style>
+        <p:txBody>
+          <a:bodyPr rtlCol="0" anchor="ctr"/>
+          <a:lstStyle/>
+          <a:p>
+            <a:pPr algn="ctr"/>
+          </a:p>
+        </p:txBody>
+      </p:sp>
+      <p:sp>
+        <p:nvSpPr>
+          <p:cNvPr id="27" name="TextBox 26"/>
+          <p:cNvSpPr txBox="1"/>
+          <p:nvPr/>
+        </p:nvSpPr>
+        <p:spPr>
+          <a:xfrm>
+            <a:off x="777240" y="6153912"/>
+            <a:ext cx="10561320" cy="201168"/>
+          </a:xfrm>
+          <a:prstGeom prst="rect">
+            <a:avLst/>
+          </a:prstGeom>
+          <a:noFill/>
+        </p:spPr>
+        <p:txBody>
+          <a:bodyPr wrap="square" lIns="36576" rIns="36576" tIns="36576" bIns="36576" anchor="t">
+            <a:spAutoFit/>
+          </a:bodyPr>
+          <a:lstStyle/>
+          <a:p>
+            <a:pPr algn="ctr"/>
+            <a:r>
+              <a:rPr sz="1300" b="1">
+                <a:solidFill>
+                  <a:srgbClr val="F0F6FC"/>
+                </a:solidFill>
+                <a:latin typeface="Aptos"/>
+              </a:rPr>
+              <a:t>Optimize total feedback time—not just step duration.</a:t>
+            </a:r>
+          </a:p>
+        </p:txBody>
+      </p:sp>
+      <p:sp>
+        <p:nvSpPr>
+          <p:cNvPr id="28" name="TextBox 27"/>
+          <p:cNvSpPr txBox="1"/>
+          <p:nvPr/>
+        </p:nvSpPr>
+        <p:spPr>
+          <a:xfrm>
+            <a:off x="640080" y="6519672"/>
+            <a:ext cx="5852160" cy="182880"/>
+          </a:xfrm>
+          <a:prstGeom prst="rect">
+            <a:avLst/>
+          </a:prstGeom>
+          <a:noFill/>
+        </p:spPr>
+        <p:txBody>
+          <a:bodyPr wrap="square" lIns="36576" rIns="36576" tIns="36576" bIns="36576" anchor="t">
+            <a:spAutoFit/>
+          </a:bodyPr>
+          <a:lstStyle/>
+          <a:p>
+            <a:pPr algn="l"/>
+            <a:r>
+              <a:rPr sz="900" b="0">
+                <a:solidFill>
+                  <a:srgbClr val="8B949E"/>
+                </a:solidFill>
+                <a:latin typeface="Aptos"/>
+              </a:rPr>
+              <a:t>GitHub Actions Office Hour · Sep 2026</a:t>
+            </a:r>
+          </a:p>
+        </p:txBody>
+      </p:sp>
+    </p:spTree>
+  </p:cSld>
+  <p:clrMapOvr>
+    <a:masterClrMapping/>
+  </p:clrMapOvr>
+</p:sld>
+</file>
+
+<file path=ppt/slides/slide17.xml><?xml version="1.0" encoding="utf-8"?>
+<p:sld xmlns:a="http://schemas.openxmlformats.org/drawingml/2006/main" xmlns:p="http://schemas.openxmlformats.org/presentationml/2006/main" xmlns:r="http://schemas.openxmlformats.org/officeDocument/2006/relationships">
+  <p:cSld>
+    <p:bg>
+      <p:bgPr>
+        <a:solidFill>
+          <a:srgbClr val="0D1117"/>
+        </a:solidFill>
+        <a:effectLst/>
+      </p:bgPr>
+    </p:bg>
+    <p:spTree>
+      <p:nvGrpSpPr>
+        <p:cNvPr id="1" name=""/>
+        <p:cNvGrpSpPr/>
+        <p:nvPr/>
+      </p:nvGrpSpPr>
+      <p:grpSpPr/>
+      <p:sp>
+        <p:nvSpPr>
+          <p:cNvPr id="2" name="TextBox 1"/>
+          <p:cNvSpPr txBox="1"/>
+          <p:nvPr/>
+        </p:nvSpPr>
+        <p:spPr>
+          <a:xfrm>
+            <a:off x="640080" y="292608"/>
+            <a:ext cx="6400800" cy="274320"/>
+          </a:xfrm>
+          <a:prstGeom prst="rect">
+            <a:avLst/>
+          </a:prstGeom>
+          <a:noFill/>
+        </p:spPr>
+        <p:txBody>
+          <a:bodyPr wrap="square" lIns="36576" rIns="36576" tIns="36576" bIns="36576" anchor="t">
+            <a:spAutoFit/>
+          </a:bodyPr>
+          <a:lstStyle/>
+          <a:p>
+            <a:pPr algn="l"/>
+            <a:r>
+              <a:rPr sz="1100" b="1">
+                <a:solidFill>
+                  <a:srgbClr val="58A6FF"/>
+                </a:solidFill>
+                <a:latin typeface="Aptos"/>
+              </a:rPr>
+              <a:t>CLOSE</a:t>
+            </a:r>
+          </a:p>
+        </p:txBody>
+      </p:sp>
+      <p:sp>
+        <p:nvSpPr>
+          <p:cNvPr id="3" name="TextBox 2"/>
+          <p:cNvSpPr txBox="1"/>
+          <p:nvPr/>
+        </p:nvSpPr>
+        <p:spPr>
+          <a:xfrm>
+            <a:off x="640080" y="667512"/>
+            <a:ext cx="10789920" cy="658368"/>
+          </a:xfrm>
+          <a:prstGeom prst="rect">
+            <a:avLst/>
+          </a:prstGeom>
+          <a:noFill/>
+        </p:spPr>
+        <p:txBody>
+          <a:bodyPr wrap="square" lIns="36576" rIns="36576" tIns="36576" bIns="36576" anchor="t">
+            <a:spAutoFit/>
+          </a:bodyPr>
+          <a:lstStyle/>
+          <a:p>
+            <a:pPr algn="l"/>
+            <a:r>
+              <a:rPr sz="3000" b="1">
+                <a:solidFill>
+                  <a:srgbClr val="F0F6FC"/>
+                </a:solidFill>
+                <a:latin typeface="Aptos"/>
+              </a:rPr>
+              <a:t>Three actions for next week</a:t>
+            </a:r>
+          </a:p>
+        </p:txBody>
+      </p:sp>
+      <p:sp>
+        <p:nvSpPr>
+          <p:cNvPr id="4" name="Rectangle 3"/>
+          <p:cNvSpPr/>
+          <p:nvPr/>
+        </p:nvSpPr>
+        <p:spPr>
+          <a:xfrm>
+            <a:off x="640080" y="1417320"/>
+            <a:ext cx="914400" cy="45720"/>
+          </a:xfrm>
+          <a:prstGeom prst="rect">
+            <a:avLst/>
+          </a:prstGeom>
+          <a:solidFill>
+            <a:srgbClr val="BC8CFF"/>
+          </a:solidFill>
+          <a:ln>
+            <a:solidFill>
+              <a:srgbClr val="BC8CFF"/>
+            </a:solidFill>
+          </a:ln>
+        </p:spPr>
+        <p:style>
+          <a:lnRef idx="1">
+            <a:schemeClr val="accent1"/>
+          </a:lnRef>
+          <a:fillRef idx="3">
+            <a:schemeClr val="accent1"/>
+          </a:fillRef>
+          <a:effectRef idx="2">
+            <a:schemeClr val="accent1"/>
+          </a:effectRef>
+          <a:fontRef idx="minor">
+            <a:schemeClr val="lt1"/>
+          </a:fontRef>
+        </p:style>
+        <p:txBody>
+          <a:bodyPr rtlCol="0" anchor="ctr"/>
+          <a:lstStyle/>
+          <a:p>
+            <a:pPr algn="ctr"/>
+          </a:p>
+        </p:txBody>
+      </p:sp>
+      <p:sp>
+        <p:nvSpPr>
+          <p:cNvPr id="5" name="TextBox 4"/>
+          <p:cNvSpPr txBox="1"/>
+          <p:nvPr/>
+        </p:nvSpPr>
+        <p:spPr>
+          <a:xfrm>
+            <a:off x="11109960" y="310896"/>
+            <a:ext cx="457200" cy="274320"/>
+          </a:xfrm>
+          <a:prstGeom prst="rect">
+            <a:avLst/>
+          </a:prstGeom>
+          <a:noFill/>
+        </p:spPr>
+        <p:txBody>
+          <a:bodyPr wrap="square" lIns="36576" rIns="36576" tIns="36576" bIns="36576" anchor="t">
+            <a:spAutoFit/>
+          </a:bodyPr>
+          <a:lstStyle/>
+          <a:p>
+            <a:pPr algn="r"/>
+            <a:r>
+              <a:rPr sz="1100" b="1">
+                <a:solidFill>
+                  <a:srgbClr val="8B949E"/>
+                </a:solidFill>
+                <a:latin typeface="Aptos"/>
+              </a:rPr>
+              <a:t>17</a:t>
+            </a:r>
+          </a:p>
+        </p:txBody>
+      </p:sp>
+      <p:sp>
+        <p:nvSpPr>
+          <p:cNvPr id="6" name="Rounded Rectangle 5"/>
+          <p:cNvSpPr/>
+          <p:nvPr/>
+        </p:nvSpPr>
+        <p:spPr>
+          <a:xfrm>
             <a:off x="731520" y="1828800"/>
             <a:ext cx="3429000" cy="3108960"/>
           </a:xfrm>
@@ -12455,6 +13674,948 @@
       <p:sp>
         <p:nvSpPr>
           <p:cNvPr id="23" name="TextBox 22"/>
+          <p:cNvSpPr txBox="1"/>
+          <p:nvPr/>
+        </p:nvSpPr>
+        <p:spPr>
+          <a:xfrm>
+            <a:off x="640080" y="6519672"/>
+            <a:ext cx="5852160" cy="182880"/>
+          </a:xfrm>
+          <a:prstGeom prst="rect">
+            <a:avLst/>
+          </a:prstGeom>
+          <a:noFill/>
+        </p:spPr>
+        <p:txBody>
+          <a:bodyPr wrap="square" lIns="36576" rIns="36576" tIns="36576" bIns="36576" anchor="t">
+            <a:spAutoFit/>
+          </a:bodyPr>
+          <a:lstStyle/>
+          <a:p>
+            <a:pPr algn="l"/>
+            <a:r>
+              <a:rPr sz="900" b="0">
+                <a:solidFill>
+                  <a:srgbClr val="8B949E"/>
+                </a:solidFill>
+                <a:latin typeface="Aptos"/>
+              </a:rPr>
+              <a:t>GitHub Actions Office Hour · Sep 2026</a:t>
+            </a:r>
+          </a:p>
+        </p:txBody>
+      </p:sp>
+    </p:spTree>
+  </p:cSld>
+  <p:clrMapOvr>
+    <a:masterClrMapping/>
+  </p:clrMapOvr>
+</p:sld>
+</file>
+
+<file path=ppt/slides/slide18.xml><?xml version="1.0" encoding="utf-8"?>
+<p:sld xmlns:a="http://schemas.openxmlformats.org/drawingml/2006/main" xmlns:p="http://schemas.openxmlformats.org/presentationml/2006/main" xmlns:r="http://schemas.openxmlformats.org/officeDocument/2006/relationships">
+  <p:cSld>
+    <p:bg>
+      <p:bgPr>
+        <a:solidFill>
+          <a:srgbClr val="0D1117"/>
+        </a:solidFill>
+        <a:effectLst/>
+      </p:bgPr>
+    </p:bg>
+    <p:spTree>
+      <p:nvGrpSpPr>
+        <p:cNvPr id="1" name=""/>
+        <p:cNvGrpSpPr/>
+        <p:nvPr/>
+      </p:nvGrpSpPr>
+      <p:grpSpPr/>
+      <p:sp>
+        <p:nvSpPr>
+          <p:cNvPr id="2" name="TextBox 1"/>
+          <p:cNvSpPr txBox="1"/>
+          <p:nvPr/>
+        </p:nvSpPr>
+        <p:spPr>
+          <a:xfrm>
+            <a:off x="640080" y="292608"/>
+            <a:ext cx="6400800" cy="274320"/>
+          </a:xfrm>
+          <a:prstGeom prst="rect">
+            <a:avLst/>
+          </a:prstGeom>
+          <a:noFill/>
+        </p:spPr>
+        <p:txBody>
+          <a:bodyPr wrap="square" lIns="36576" rIns="36576" tIns="36576" bIns="36576" anchor="t">
+            <a:spAutoFit/>
+          </a:bodyPr>
+          <a:lstStyle/>
+          <a:p>
+            <a:pPr algn="l"/>
+            <a:r>
+              <a:rPr sz="1100" b="1">
+                <a:solidFill>
+                  <a:srgbClr val="58A6FF"/>
+                </a:solidFill>
+                <a:latin typeface="Aptos"/>
+              </a:rPr>
+              <a:t>GITHUB CHANGELOG</a:t>
+            </a:r>
+          </a:p>
+        </p:txBody>
+      </p:sp>
+      <p:sp>
+        <p:nvSpPr>
+          <p:cNvPr id="3" name="TextBox 2"/>
+          <p:cNvSpPr txBox="1"/>
+          <p:nvPr/>
+        </p:nvSpPr>
+        <p:spPr>
+          <a:xfrm>
+            <a:off x="640080" y="667512"/>
+            <a:ext cx="10789920" cy="658368"/>
+          </a:xfrm>
+          <a:prstGeom prst="rect">
+            <a:avLst/>
+          </a:prstGeom>
+          <a:noFill/>
+        </p:spPr>
+        <p:txBody>
+          <a:bodyPr wrap="square" lIns="36576" rIns="36576" tIns="36576" bIns="36576" anchor="t">
+            <a:spAutoFit/>
+          </a:bodyPr>
+          <a:lstStyle/>
+          <a:p>
+            <a:pPr algn="l"/>
+            <a:r>
+              <a:rPr sz="3000" b="1">
+                <a:solidFill>
+                  <a:srgbClr val="F0F6FC"/>
+                </a:solidFill>
+                <a:latin typeface="Aptos"/>
+              </a:rPr>
+              <a:t>Feature references</a:t>
+            </a:r>
+          </a:p>
+        </p:txBody>
+      </p:sp>
+      <p:sp>
+        <p:nvSpPr>
+          <p:cNvPr id="4" name="Rectangle 3"/>
+          <p:cNvSpPr/>
+          <p:nvPr/>
+        </p:nvSpPr>
+        <p:spPr>
+          <a:xfrm>
+            <a:off x="640080" y="1417320"/>
+            <a:ext cx="914400" cy="45720"/>
+          </a:xfrm>
+          <a:prstGeom prst="rect">
+            <a:avLst/>
+          </a:prstGeom>
+          <a:solidFill>
+            <a:srgbClr val="BC8CFF"/>
+          </a:solidFill>
+          <a:ln>
+            <a:solidFill>
+              <a:srgbClr val="BC8CFF"/>
+            </a:solidFill>
+          </a:ln>
+        </p:spPr>
+        <p:style>
+          <a:lnRef idx="1">
+            <a:schemeClr val="accent1"/>
+          </a:lnRef>
+          <a:fillRef idx="3">
+            <a:schemeClr val="accent1"/>
+          </a:fillRef>
+          <a:effectRef idx="2">
+            <a:schemeClr val="accent1"/>
+          </a:effectRef>
+          <a:fontRef idx="minor">
+            <a:schemeClr val="lt1"/>
+          </a:fontRef>
+        </p:style>
+        <p:txBody>
+          <a:bodyPr rtlCol="0" anchor="ctr"/>
+          <a:lstStyle/>
+          <a:p>
+            <a:pPr algn="ctr"/>
+          </a:p>
+        </p:txBody>
+      </p:sp>
+      <p:sp>
+        <p:nvSpPr>
+          <p:cNvPr id="5" name="TextBox 4"/>
+          <p:cNvSpPr txBox="1"/>
+          <p:nvPr/>
+        </p:nvSpPr>
+        <p:spPr>
+          <a:xfrm>
+            <a:off x="11109960" y="310896"/>
+            <a:ext cx="457200" cy="274320"/>
+          </a:xfrm>
+          <a:prstGeom prst="rect">
+            <a:avLst/>
+          </a:prstGeom>
+          <a:noFill/>
+        </p:spPr>
+        <p:txBody>
+          <a:bodyPr wrap="square" lIns="36576" rIns="36576" tIns="36576" bIns="36576" anchor="t">
+            <a:spAutoFit/>
+          </a:bodyPr>
+          <a:lstStyle/>
+          <a:p>
+            <a:pPr algn="r"/>
+            <a:r>
+              <a:rPr sz="1100" b="1">
+                <a:solidFill>
+                  <a:srgbClr val="8B949E"/>
+                </a:solidFill>
+                <a:latin typeface="Aptos"/>
+              </a:rPr>
+              <a:t>18</a:t>
+            </a:r>
+          </a:p>
+        </p:txBody>
+      </p:sp>
+      <p:sp>
+        <p:nvSpPr>
+          <p:cNvPr id="6" name="Rounded Rectangle 5"/>
+          <p:cNvSpPr/>
+          <p:nvPr/>
+        </p:nvSpPr>
+        <p:spPr>
+          <a:xfrm>
+            <a:off x="731520" y="1664208"/>
+            <a:ext cx="10744200" cy="612648"/>
+          </a:xfrm>
+          <a:prstGeom prst="roundRect">
+            <a:avLst/>
+          </a:prstGeom>
+          <a:solidFill>
+            <a:srgbClr val="161B22"/>
+          </a:solidFill>
+          <a:ln>
+            <a:solidFill>
+              <a:srgbClr val="21262D"/>
+            </a:solidFill>
+          </a:ln>
+        </p:spPr>
+        <p:style>
+          <a:lnRef idx="1">
+            <a:schemeClr val="accent1"/>
+          </a:lnRef>
+          <a:fillRef idx="3">
+            <a:schemeClr val="accent1"/>
+          </a:fillRef>
+          <a:effectRef idx="2">
+            <a:schemeClr val="accent1"/>
+          </a:effectRef>
+          <a:fontRef idx="minor">
+            <a:schemeClr val="lt1"/>
+          </a:fontRef>
+        </p:style>
+        <p:txBody>
+          <a:bodyPr rtlCol="0" anchor="ctr"/>
+          <a:lstStyle/>
+          <a:p>
+            <a:pPr algn="ctr"/>
+          </a:p>
+        </p:txBody>
+      </p:sp>
+      <p:sp>
+        <p:nvSpPr>
+          <p:cNvPr id="7" name="TextBox 6"/>
+          <p:cNvSpPr txBox="1"/>
+          <p:nvPr/>
+        </p:nvSpPr>
+        <p:spPr>
+          <a:xfrm>
+            <a:off x="960120" y="1755648"/>
+            <a:ext cx="4206240" cy="228600"/>
+          </a:xfrm>
+          <a:prstGeom prst="rect">
+            <a:avLst/>
+          </a:prstGeom>
+          <a:noFill/>
+        </p:spPr>
+        <p:txBody>
+          <a:bodyPr wrap="square" lIns="36576" rIns="36576" tIns="36576" bIns="36576" anchor="t">
+            <a:spAutoFit/>
+          </a:bodyPr>
+          <a:lstStyle/>
+          <a:p>
+            <a:pPr algn="l"/>
+            <a:r>
+              <a:rPr sz="1400" b="1">
+                <a:solidFill>
+                  <a:srgbClr val="F0F6FC"/>
+                </a:solidFill>
+                <a:latin typeface="Aptos"/>
+              </a:rPr>
+              <a:t>Windows 11 Arm64 with Visual Studio 2026</a:t>
+            </a:r>
+          </a:p>
+        </p:txBody>
+      </p:sp>
+      <p:sp>
+        <p:nvSpPr>
+          <p:cNvPr id="8" name="TextBox 7"/>
+          <p:cNvSpPr txBox="1"/>
+          <p:nvPr/>
+        </p:nvSpPr>
+        <p:spPr>
+          <a:xfrm>
+            <a:off x="5074920" y="1746504"/>
+            <a:ext cx="6080760" cy="347472"/>
+          </a:xfrm>
+          <a:prstGeom prst="rect">
+            <a:avLst/>
+          </a:prstGeom>
+          <a:noFill/>
+        </p:spPr>
+        <p:txBody>
+          <a:bodyPr wrap="square" lIns="36576" rIns="36576" tIns="36576" bIns="36576" anchor="t">
+            <a:spAutoFit/>
+          </a:bodyPr>
+          <a:lstStyle/>
+          <a:p>
+            <a:pPr algn="l"/>
+            <a:r>
+              <a:rPr sz="900" b="0" u="sng">
+                <a:solidFill>
+                  <a:srgbClr val="58A6FF"/>
+                </a:solidFill>
+                <a:latin typeface="Cascadia Mono"/>
+                <a:hlinkClick r:id="rId2"/>
+              </a:rPr>
+              <a:t>https://github.blog/changelog/2026-08-20-windows-11-arm64-vs2026-image-generally-available</a:t>
+            </a:r>
+          </a:p>
+        </p:txBody>
+      </p:sp>
+      <p:sp>
+        <p:nvSpPr>
+          <p:cNvPr id="9" name="Rounded Rectangle 8"/>
+          <p:cNvSpPr/>
+          <p:nvPr/>
+        </p:nvSpPr>
+        <p:spPr>
+          <a:xfrm>
+            <a:off x="731520" y="2414016"/>
+            <a:ext cx="10744200" cy="612648"/>
+          </a:xfrm>
+          <a:prstGeom prst="roundRect">
+            <a:avLst/>
+          </a:prstGeom>
+          <a:solidFill>
+            <a:srgbClr val="161B22"/>
+          </a:solidFill>
+          <a:ln>
+            <a:solidFill>
+              <a:srgbClr val="21262D"/>
+            </a:solidFill>
+          </a:ln>
+        </p:spPr>
+        <p:style>
+          <a:lnRef idx="1">
+            <a:schemeClr val="accent1"/>
+          </a:lnRef>
+          <a:fillRef idx="3">
+            <a:schemeClr val="accent1"/>
+          </a:fillRef>
+          <a:effectRef idx="2">
+            <a:schemeClr val="accent1"/>
+          </a:effectRef>
+          <a:fontRef idx="minor">
+            <a:schemeClr val="lt1"/>
+          </a:fontRef>
+        </p:style>
+        <p:txBody>
+          <a:bodyPr rtlCol="0" anchor="ctr"/>
+          <a:lstStyle/>
+          <a:p>
+            <a:pPr algn="ctr"/>
+          </a:p>
+        </p:txBody>
+      </p:sp>
+      <p:sp>
+        <p:nvSpPr>
+          <p:cNvPr id="10" name="TextBox 9"/>
+          <p:cNvSpPr txBox="1"/>
+          <p:nvPr/>
+        </p:nvSpPr>
+        <p:spPr>
+          <a:xfrm>
+            <a:off x="960120" y="2505456"/>
+            <a:ext cx="4206240" cy="228600"/>
+          </a:xfrm>
+          <a:prstGeom prst="rect">
+            <a:avLst/>
+          </a:prstGeom>
+          <a:noFill/>
+        </p:spPr>
+        <p:txBody>
+          <a:bodyPr wrap="square" lIns="36576" rIns="36576" tIns="36576" bIns="36576" anchor="t">
+            <a:spAutoFit/>
+          </a:bodyPr>
+          <a:lstStyle/>
+          <a:p>
+            <a:pPr algn="l"/>
+            <a:r>
+              <a:rPr sz="1400" b="1">
+                <a:solidFill>
+                  <a:srgbClr val="F0F6FC"/>
+                </a:solidFill>
+                <a:latin typeface="Aptos"/>
+              </a:rPr>
+              <a:t>Separate GitHub Actions path for GitHub Code Quality</a:t>
+            </a:r>
+          </a:p>
+        </p:txBody>
+      </p:sp>
+      <p:sp>
+        <p:nvSpPr>
+          <p:cNvPr id="11" name="TextBox 10"/>
+          <p:cNvSpPr txBox="1"/>
+          <p:nvPr/>
+        </p:nvSpPr>
+        <p:spPr>
+          <a:xfrm>
+            <a:off x="5074920" y="2496312"/>
+            <a:ext cx="6080760" cy="347472"/>
+          </a:xfrm>
+          <a:prstGeom prst="rect">
+            <a:avLst/>
+          </a:prstGeom>
+          <a:noFill/>
+        </p:spPr>
+        <p:txBody>
+          <a:bodyPr wrap="square" lIns="36576" rIns="36576" tIns="36576" bIns="36576" anchor="t">
+            <a:spAutoFit/>
+          </a:bodyPr>
+          <a:lstStyle/>
+          <a:p>
+            <a:pPr algn="l"/>
+            <a:r>
+              <a:rPr sz="900" b="0" u="sng">
+                <a:solidFill>
+                  <a:srgbClr val="58A6FF"/>
+                </a:solidFill>
+                <a:latin typeface="Cascadia Mono"/>
+                <a:hlinkClick r:id="rId3"/>
+              </a:rPr>
+              <a:t>https://github.blog/changelog/2026-08-20-separate-github-actions-path-for-github-code-quality</a:t>
+            </a:r>
+          </a:p>
+        </p:txBody>
+      </p:sp>
+      <p:sp>
+        <p:nvSpPr>
+          <p:cNvPr id="12" name="Rounded Rectangle 11"/>
+          <p:cNvSpPr/>
+          <p:nvPr/>
+        </p:nvSpPr>
+        <p:spPr>
+          <a:xfrm>
+            <a:off x="731520" y="3163824"/>
+            <a:ext cx="10744200" cy="612648"/>
+          </a:xfrm>
+          <a:prstGeom prst="roundRect">
+            <a:avLst/>
+          </a:prstGeom>
+          <a:solidFill>
+            <a:srgbClr val="161B22"/>
+          </a:solidFill>
+          <a:ln>
+            <a:solidFill>
+              <a:srgbClr val="21262D"/>
+            </a:solidFill>
+          </a:ln>
+        </p:spPr>
+        <p:style>
+          <a:lnRef idx="1">
+            <a:schemeClr val="accent1"/>
+          </a:lnRef>
+          <a:fillRef idx="3">
+            <a:schemeClr val="accent1"/>
+          </a:fillRef>
+          <a:effectRef idx="2">
+            <a:schemeClr val="accent1"/>
+          </a:effectRef>
+          <a:fontRef idx="minor">
+            <a:schemeClr val="lt1"/>
+          </a:fontRef>
+        </p:style>
+        <p:txBody>
+          <a:bodyPr rtlCol="0" anchor="ctr"/>
+          <a:lstStyle/>
+          <a:p>
+            <a:pPr algn="ctr"/>
+          </a:p>
+        </p:txBody>
+      </p:sp>
+      <p:sp>
+        <p:nvSpPr>
+          <p:cNvPr id="13" name="TextBox 12"/>
+          <p:cNvSpPr txBox="1"/>
+          <p:nvPr/>
+        </p:nvSpPr>
+        <p:spPr>
+          <a:xfrm>
+            <a:off x="960120" y="3255264"/>
+            <a:ext cx="4206240" cy="228600"/>
+          </a:xfrm>
+          <a:prstGeom prst="rect">
+            <a:avLst/>
+          </a:prstGeom>
+          <a:noFill/>
+        </p:spPr>
+        <p:txBody>
+          <a:bodyPr wrap="square" lIns="36576" rIns="36576" tIns="36576" bIns="36576" anchor="t">
+            <a:spAutoFit/>
+          </a:bodyPr>
+          <a:lstStyle/>
+          <a:p>
+            <a:pPr algn="l"/>
+            <a:r>
+              <a:rPr sz="1400" b="1">
+                <a:solidFill>
+                  <a:srgbClr val="F0F6FC"/>
+                </a:solidFill>
+                <a:latin typeface="Aptos"/>
+              </a:rPr>
+              <a:t>Actions retention for checks, workflow runs, and statuses</a:t>
+            </a:r>
+          </a:p>
+        </p:txBody>
+      </p:sp>
+      <p:sp>
+        <p:nvSpPr>
+          <p:cNvPr id="14" name="TextBox 13"/>
+          <p:cNvSpPr txBox="1"/>
+          <p:nvPr/>
+        </p:nvSpPr>
+        <p:spPr>
+          <a:xfrm>
+            <a:off x="5074920" y="3246120"/>
+            <a:ext cx="6080760" cy="347472"/>
+          </a:xfrm>
+          <a:prstGeom prst="rect">
+            <a:avLst/>
+          </a:prstGeom>
+          <a:noFill/>
+        </p:spPr>
+        <p:txBody>
+          <a:bodyPr wrap="square" lIns="36576" rIns="36576" tIns="36576" bIns="36576" anchor="t">
+            <a:spAutoFit/>
+          </a:bodyPr>
+          <a:lstStyle/>
+          <a:p>
+            <a:pPr algn="l"/>
+            <a:r>
+              <a:rPr sz="900" b="0" u="sng">
+                <a:solidFill>
+                  <a:srgbClr val="58A6FF"/>
+                </a:solidFill>
+                <a:latin typeface="Cascadia Mono"/>
+                <a:hlinkClick r:id="rId4"/>
+              </a:rPr>
+              <a:t>https://github.blog/changelog/2026-08-27-actions-retention-will-cover-checks-workflow-runs-and-statuses</a:t>
+            </a:r>
+          </a:p>
+        </p:txBody>
+      </p:sp>
+      <p:sp>
+        <p:nvSpPr>
+          <p:cNvPr id="15" name="Rounded Rectangle 14"/>
+          <p:cNvSpPr/>
+          <p:nvPr/>
+        </p:nvSpPr>
+        <p:spPr>
+          <a:xfrm>
+            <a:off x="731520" y="3913632"/>
+            <a:ext cx="10744200" cy="612648"/>
+          </a:xfrm>
+          <a:prstGeom prst="roundRect">
+            <a:avLst/>
+          </a:prstGeom>
+          <a:solidFill>
+            <a:srgbClr val="161B22"/>
+          </a:solidFill>
+          <a:ln>
+            <a:solidFill>
+              <a:srgbClr val="21262D"/>
+            </a:solidFill>
+          </a:ln>
+        </p:spPr>
+        <p:style>
+          <a:lnRef idx="1">
+            <a:schemeClr val="accent1"/>
+          </a:lnRef>
+          <a:fillRef idx="3">
+            <a:schemeClr val="accent1"/>
+          </a:fillRef>
+          <a:effectRef idx="2">
+            <a:schemeClr val="accent1"/>
+          </a:effectRef>
+          <a:fontRef idx="minor">
+            <a:schemeClr val="lt1"/>
+          </a:fontRef>
+        </p:style>
+        <p:txBody>
+          <a:bodyPr rtlCol="0" anchor="ctr"/>
+          <a:lstStyle/>
+          <a:p>
+            <a:pPr algn="ctr"/>
+          </a:p>
+        </p:txBody>
+      </p:sp>
+      <p:sp>
+        <p:nvSpPr>
+          <p:cNvPr id="16" name="TextBox 15"/>
+          <p:cNvSpPr txBox="1"/>
+          <p:nvPr/>
+        </p:nvSpPr>
+        <p:spPr>
+          <a:xfrm>
+            <a:off x="960120" y="4005072"/>
+            <a:ext cx="4206240" cy="228600"/>
+          </a:xfrm>
+          <a:prstGeom prst="rect">
+            <a:avLst/>
+          </a:prstGeom>
+          <a:noFill/>
+        </p:spPr>
+        <p:txBody>
+          <a:bodyPr wrap="square" lIns="36576" rIns="36576" tIns="36576" bIns="36576" anchor="t">
+            <a:spAutoFit/>
+          </a:bodyPr>
+          <a:lstStyle/>
+          <a:p>
+            <a:pPr algn="l"/>
+            <a:r>
+              <a:rPr sz="1400" b="1">
+                <a:solidFill>
+                  <a:srgbClr val="F0F6FC"/>
+                </a:solidFill>
+                <a:latin typeface="Aptos"/>
+              </a:rPr>
+              <a:t>REST API for runner version deprecations</a:t>
+            </a:r>
+          </a:p>
+        </p:txBody>
+      </p:sp>
+      <p:sp>
+        <p:nvSpPr>
+          <p:cNvPr id="17" name="TextBox 16"/>
+          <p:cNvSpPr txBox="1"/>
+          <p:nvPr/>
+        </p:nvSpPr>
+        <p:spPr>
+          <a:xfrm>
+            <a:off x="5074920" y="3995928"/>
+            <a:ext cx="6080760" cy="347472"/>
+          </a:xfrm>
+          <a:prstGeom prst="rect">
+            <a:avLst/>
+          </a:prstGeom>
+          <a:noFill/>
+        </p:spPr>
+        <p:txBody>
+          <a:bodyPr wrap="square" lIns="36576" rIns="36576" tIns="36576" bIns="36576" anchor="t">
+            <a:spAutoFit/>
+          </a:bodyPr>
+          <a:lstStyle/>
+          <a:p>
+            <a:pPr algn="l"/>
+            <a:r>
+              <a:rPr sz="900" b="0" u="sng">
+                <a:solidFill>
+                  <a:srgbClr val="58A6FF"/>
+                </a:solidFill>
+                <a:latin typeface="Cascadia Mono"/>
+                <a:hlinkClick r:id="rId5"/>
+              </a:rPr>
+              <a:t>https://github.blog/changelog/2026-09-03-github-actions-early-september-2026-updates</a:t>
+            </a:r>
+          </a:p>
+        </p:txBody>
+      </p:sp>
+      <p:sp>
+        <p:nvSpPr>
+          <p:cNvPr id="18" name="Rounded Rectangle 17"/>
+          <p:cNvSpPr/>
+          <p:nvPr/>
+        </p:nvSpPr>
+        <p:spPr>
+          <a:xfrm>
+            <a:off x="731520" y="4663440"/>
+            <a:ext cx="10744200" cy="612648"/>
+          </a:xfrm>
+          <a:prstGeom prst="roundRect">
+            <a:avLst/>
+          </a:prstGeom>
+          <a:solidFill>
+            <a:srgbClr val="161B22"/>
+          </a:solidFill>
+          <a:ln>
+            <a:solidFill>
+              <a:srgbClr val="21262D"/>
+            </a:solidFill>
+          </a:ln>
+        </p:spPr>
+        <p:style>
+          <a:lnRef idx="1">
+            <a:schemeClr val="accent1"/>
+          </a:lnRef>
+          <a:fillRef idx="3">
+            <a:schemeClr val="accent1"/>
+          </a:fillRef>
+          <a:effectRef idx="2">
+            <a:schemeClr val="accent1"/>
+          </a:effectRef>
+          <a:fontRef idx="minor">
+            <a:schemeClr val="lt1"/>
+          </a:fontRef>
+        </p:style>
+        <p:txBody>
+          <a:bodyPr rtlCol="0" anchor="ctr"/>
+          <a:lstStyle/>
+          <a:p>
+            <a:pPr algn="ctr"/>
+          </a:p>
+        </p:txBody>
+      </p:sp>
+      <p:sp>
+        <p:nvSpPr>
+          <p:cNvPr id="19" name="TextBox 18"/>
+          <p:cNvSpPr txBox="1"/>
+          <p:nvPr/>
+        </p:nvSpPr>
+        <p:spPr>
+          <a:xfrm>
+            <a:off x="960120" y="4754879"/>
+            <a:ext cx="4206240" cy="228600"/>
+          </a:xfrm>
+          <a:prstGeom prst="rect">
+            <a:avLst/>
+          </a:prstGeom>
+          <a:noFill/>
+        </p:spPr>
+        <p:txBody>
+          <a:bodyPr wrap="square" lIns="36576" rIns="36576" tIns="36576" bIns="36576" anchor="t">
+            <a:spAutoFit/>
+          </a:bodyPr>
+          <a:lstStyle/>
+          <a:p>
+            <a:pPr algn="l"/>
+            <a:r>
+              <a:rPr sz="1400" b="1">
+                <a:solidFill>
+                  <a:srgbClr val="F0F6FC"/>
+                </a:solidFill>
+                <a:latin typeface="Aptos"/>
+              </a:rPr>
+              <a:t>vulnerability-alerts permission for GITHUB_TOKEN</a:t>
+            </a:r>
+          </a:p>
+        </p:txBody>
+      </p:sp>
+      <p:sp>
+        <p:nvSpPr>
+          <p:cNvPr id="20" name="TextBox 19"/>
+          <p:cNvSpPr txBox="1"/>
+          <p:nvPr/>
+        </p:nvSpPr>
+        <p:spPr>
+          <a:xfrm>
+            <a:off x="5074920" y="4745736"/>
+            <a:ext cx="6080760" cy="347472"/>
+          </a:xfrm>
+          <a:prstGeom prst="rect">
+            <a:avLst/>
+          </a:prstGeom>
+          <a:noFill/>
+        </p:spPr>
+        <p:txBody>
+          <a:bodyPr wrap="square" lIns="36576" rIns="36576" tIns="36576" bIns="36576" anchor="t">
+            <a:spAutoFit/>
+          </a:bodyPr>
+          <a:lstStyle/>
+          <a:p>
+            <a:pPr algn="l"/>
+            <a:r>
+              <a:rPr sz="900" b="0" u="sng">
+                <a:solidFill>
+                  <a:srgbClr val="58A6FF"/>
+                </a:solidFill>
+                <a:latin typeface="Cascadia Mono"/>
+                <a:hlinkClick r:id="rId5"/>
+              </a:rPr>
+              <a:t>https://github.blog/changelog/2026-09-03-github-actions-early-september-2026-updates</a:t>
+            </a:r>
+          </a:p>
+        </p:txBody>
+      </p:sp>
+      <p:sp>
+        <p:nvSpPr>
+          <p:cNvPr id="21" name="Rounded Rectangle 20"/>
+          <p:cNvSpPr/>
+          <p:nvPr/>
+        </p:nvSpPr>
+        <p:spPr>
+          <a:xfrm>
+            <a:off x="731520" y="5413248"/>
+            <a:ext cx="10744200" cy="612648"/>
+          </a:xfrm>
+          <a:prstGeom prst="roundRect">
+            <a:avLst/>
+          </a:prstGeom>
+          <a:solidFill>
+            <a:srgbClr val="161B22"/>
+          </a:solidFill>
+          <a:ln>
+            <a:solidFill>
+              <a:srgbClr val="21262D"/>
+            </a:solidFill>
+          </a:ln>
+        </p:spPr>
+        <p:style>
+          <a:lnRef idx="1">
+            <a:schemeClr val="accent1"/>
+          </a:lnRef>
+          <a:fillRef idx="3">
+            <a:schemeClr val="accent1"/>
+          </a:fillRef>
+          <a:effectRef idx="2">
+            <a:schemeClr val="accent1"/>
+          </a:effectRef>
+          <a:fontRef idx="minor">
+            <a:schemeClr val="lt1"/>
+          </a:fontRef>
+        </p:style>
+        <p:txBody>
+          <a:bodyPr rtlCol="0" anchor="ctr"/>
+          <a:lstStyle/>
+          <a:p>
+            <a:pPr algn="ctr"/>
+          </a:p>
+        </p:txBody>
+      </p:sp>
+      <p:sp>
+        <p:nvSpPr>
+          <p:cNvPr id="22" name="TextBox 21"/>
+          <p:cNvSpPr txBox="1"/>
+          <p:nvPr/>
+        </p:nvSpPr>
+        <p:spPr>
+          <a:xfrm>
+            <a:off x="960120" y="5504688"/>
+            <a:ext cx="4206240" cy="228600"/>
+          </a:xfrm>
+          <a:prstGeom prst="rect">
+            <a:avLst/>
+          </a:prstGeom>
+          <a:noFill/>
+        </p:spPr>
+        <p:txBody>
+          <a:bodyPr wrap="square" lIns="36576" rIns="36576" tIns="36576" bIns="36576" anchor="t">
+            <a:spAutoFit/>
+          </a:bodyPr>
+          <a:lstStyle/>
+          <a:p>
+            <a:pPr algn="l"/>
+            <a:r>
+              <a:rPr sz="1400" b="1">
+                <a:solidFill>
+                  <a:srgbClr val="F0F6FC"/>
+                </a:solidFill>
+                <a:latin typeface="Aptos"/>
+              </a:rPr>
+              <a:t>Reusable workflow job context properties</a:t>
+            </a:r>
+          </a:p>
+        </p:txBody>
+      </p:sp>
+      <p:sp>
+        <p:nvSpPr>
+          <p:cNvPr id="23" name="TextBox 22"/>
+          <p:cNvSpPr txBox="1"/>
+          <p:nvPr/>
+        </p:nvSpPr>
+        <p:spPr>
+          <a:xfrm>
+            <a:off x="5074920" y="5495544"/>
+            <a:ext cx="6080760" cy="347472"/>
+          </a:xfrm>
+          <a:prstGeom prst="rect">
+            <a:avLst/>
+          </a:prstGeom>
+          <a:noFill/>
+        </p:spPr>
+        <p:txBody>
+          <a:bodyPr wrap="square" lIns="36576" rIns="36576" tIns="36576" bIns="36576" anchor="t">
+            <a:spAutoFit/>
+          </a:bodyPr>
+          <a:lstStyle/>
+          <a:p>
+            <a:pPr algn="l"/>
+            <a:r>
+              <a:rPr sz="900" b="0" u="sng">
+                <a:solidFill>
+                  <a:srgbClr val="58A6FF"/>
+                </a:solidFill>
+                <a:latin typeface="Cascadia Mono"/>
+                <a:hlinkClick r:id="rId5"/>
+              </a:rPr>
+              <a:t>https://github.blog/changelog/2026-09-03-github-actions-early-september-2026-updates</a:t>
+            </a:r>
+          </a:p>
+        </p:txBody>
+      </p:sp>
+      <p:sp>
+        <p:nvSpPr>
+          <p:cNvPr id="24" name="TextBox 23"/>
+          <p:cNvSpPr txBox="1"/>
+          <p:nvPr/>
+        </p:nvSpPr>
+        <p:spPr>
+          <a:xfrm>
+            <a:off x="777240" y="6236208"/>
+            <a:ext cx="10607040" cy="228600"/>
+          </a:xfrm>
+          <a:prstGeom prst="rect">
+            <a:avLst/>
+          </a:prstGeom>
+          <a:noFill/>
+        </p:spPr>
+        <p:txBody>
+          <a:bodyPr wrap="square" lIns="36576" rIns="36576" tIns="36576" bIns="36576" anchor="t">
+            <a:spAutoFit/>
+          </a:bodyPr>
+          <a:lstStyle/>
+          <a:p>
+            <a:pPr algn="ctr"/>
+            <a:r>
+              <a:rPr sz="1100" b="0">
+                <a:solidFill>
+                  <a:srgbClr val="8B949E"/>
+                </a:solidFill>
+                <a:latin typeface="Aptos"/>
+              </a:rPr>
+              <a:t>Links are clickable in Slide Show and Normal view.</a:t>
+            </a:r>
+          </a:p>
+        </p:txBody>
+      </p:sp>
+      <p:sp>
+        <p:nvSpPr>
+          <p:cNvPr id="25" name="TextBox 24"/>
           <p:cNvSpPr txBox="1"/>
           <p:nvPr/>
         </p:nvSpPr>
@@ -13403,7 +15564,7 @@
                 </a:solidFill>
                 <a:latin typeface="Aptos"/>
               </a:rPr>
-              <a:t>Two demos</a:t>
+              <a:t>Three demos</a:t>
             </a:r>
           </a:p>
         </p:txBody>

</xml_diff>